<commit_message>
Finalize K-Means report and presentation with verified quality results
</commit_message>
<xml_diff>
--- a/docs/final_submission/Group7_Parallel_KMeans_Final_Presentation.pptx
+++ b/docs/final_submission/Group7_Parallel_KMeans_Final_Presentation.pptx
@@ -30,6 +30,7 @@
     <p:sldId id="277" r:id="rId21"/>
     <p:sldId id="269" r:id="rId22"/>
     <p:sldId id="278" r:id="rId23"/>
+    <p:sldId id="279" r:id="rId30"/>
     <p:sldId id="270" r:id="rId24"/>
   </p:sldIdLst>
   <p:sldSz cx="12192000" cy="6858000"/>
@@ -15695,6 +15696,1082 @@
             </a:pPr>
             <a:r>
               <a:t>[5] Apache Software Foundation, “RDD Programming Guide,” Spark Documentation.</a:t>
+            </a:r>
+          </a:p>
+        </p:txBody>
+      </p:sp>
+    </p:spTree>
+  </p:cSld>
+  <p:clrMapOvr>
+    <a:masterClrMapping/>
+  </p:clrMapOvr>
+</p:sld>
+</file>
+
+<file path=ppt/slides/slide24.xml><?xml version="1.0" encoding="utf-8"?>
+<p:sld xmlns:a="http://schemas.openxmlformats.org/drawingml/2006/main" xmlns:p="http://schemas.openxmlformats.org/presentationml/2006/main" xmlns:r="http://schemas.openxmlformats.org/officeDocument/2006/relationships">
+  <p:cSld>
+    <p:bg>
+      <p:bgPr>
+        <a:solidFill>
+          <a:srgbClr val="0D192D"/>
+        </a:solidFill>
+        <a:effectLst/>
+      </p:bgPr>
+    </p:bg>
+    <p:spTree>
+      <p:nvGrpSpPr>
+        <p:cNvPr id="1" name=""/>
+        <p:cNvGrpSpPr/>
+        <p:nvPr/>
+      </p:nvGrpSpPr>
+      <p:grpSpPr/>
+      <p:sp>
+        <p:nvSpPr>
+          <p:cNvPr id="2" name="TextBox 1"/>
+          <p:cNvSpPr txBox="1"/>
+          <p:nvPr/>
+        </p:nvSpPr>
+        <p:spPr>
+          <a:xfrm>
+            <a:off x="594360" y="347472"/>
+            <a:ext cx="11003280" cy="329184"/>
+          </a:xfrm>
+          <a:prstGeom prst="rect">
+            <a:avLst/>
+          </a:prstGeom>
+          <a:noFill/>
+        </p:spPr>
+        <p:txBody>
+          <a:bodyPr wrap="square">
+            <a:spAutoFit/>
+          </a:bodyPr>
+          <a:lstStyle/>
+          <a:p>
+            <a:pPr>
+              <a:defRPr sz="1400" b="1">
+                <a:solidFill>
+                  <a:srgbClr val="5BCCE6"/>
+                </a:solidFill>
+              </a:defRPr>
+            </a:pPr>
+            <a:r>
+              <a:t>SUPPLEMENTARY VERIFICATION</a:t>
+            </a:r>
+          </a:p>
+        </p:txBody>
+      </p:sp>
+      <p:sp>
+        <p:nvSpPr>
+          <p:cNvPr id="3" name="TextBox 2"/>
+          <p:cNvSpPr txBox="1"/>
+          <p:nvPr/>
+        </p:nvSpPr>
+        <p:spPr>
+          <a:xfrm>
+            <a:off x="594360" y="822960"/>
+            <a:ext cx="11094720" cy="640080"/>
+          </a:xfrm>
+          <a:prstGeom prst="rect">
+            <a:avLst/>
+          </a:prstGeom>
+          <a:noFill/>
+        </p:spPr>
+        <p:txBody>
+          <a:bodyPr wrap="square">
+            <a:spAutoFit/>
+          </a:bodyPr>
+          <a:lstStyle/>
+          <a:p>
+            <a:pPr>
+              <a:defRPr sz="2700" b="1">
+                <a:solidFill>
+                  <a:srgbClr val="EBF2FA"/>
+                </a:solidFill>
+              </a:defRPr>
+            </a:pPr>
+            <a:r>
+              <a:t>Independent SSE &amp; cluster-quality checks</a:t>
+            </a:r>
+          </a:p>
+        </p:txBody>
+      </p:sp>
+      <p:sp>
+        <p:nvSpPr>
+          <p:cNvPr id="4" name="TextBox 3"/>
+          <p:cNvSpPr txBox="1"/>
+          <p:nvPr/>
+        </p:nvSpPr>
+        <p:spPr>
+          <a:xfrm>
+            <a:off x="594360" y="1527048"/>
+            <a:ext cx="11094720" cy="365760"/>
+          </a:xfrm>
+          <a:prstGeom prst="rect">
+            <a:avLst/>
+          </a:prstGeom>
+          <a:noFill/>
+        </p:spPr>
+        <p:txBody>
+          <a:bodyPr wrap="square">
+            <a:spAutoFit/>
+          </a:bodyPr>
+          <a:lstStyle/>
+          <a:p>
+            <a:pPr>
+              <a:defRPr sz="1600" b="0">
+                <a:solidFill>
+                  <a:srgbClr val="EBF2FA"/>
+                </a:solidFill>
+              </a:defRPr>
+            </a:pPr>
+            <a:r>
+              <a:t>1,000 records  •  2 partitions  •  seed 42  •  5 clusters</a:t>
+            </a:r>
+          </a:p>
+        </p:txBody>
+      </p:sp>
+      <p:sp>
+        <p:nvSpPr>
+          <p:cNvPr id="5" name="TextBox 4"/>
+          <p:cNvSpPr txBox="1"/>
+          <p:nvPr/>
+        </p:nvSpPr>
+        <p:spPr>
+          <a:xfrm>
+            <a:off x="594360" y="2057400"/>
+            <a:ext cx="3977639" cy="329184"/>
+          </a:xfrm>
+          <a:prstGeom prst="rect">
+            <a:avLst/>
+          </a:prstGeom>
+          <a:noFill/>
+        </p:spPr>
+        <p:txBody>
+          <a:bodyPr wrap="square">
+            <a:spAutoFit/>
+          </a:bodyPr>
+          <a:lstStyle/>
+          <a:p>
+            <a:pPr>
+              <a:defRPr sz="1500" b="1">
+                <a:solidFill>
+                  <a:srgbClr val="5BCCE6"/>
+                </a:solidFill>
+              </a:defRPr>
+            </a:pPr>
+            <a:r>
+              <a:t>Dataset / method</a:t>
+            </a:r>
+          </a:p>
+        </p:txBody>
+      </p:sp>
+      <p:sp>
+        <p:nvSpPr>
+          <p:cNvPr id="6" name="TextBox 5"/>
+          <p:cNvSpPr txBox="1"/>
+          <p:nvPr/>
+        </p:nvSpPr>
+        <p:spPr>
+          <a:xfrm>
+            <a:off x="4736592" y="2057400"/>
+            <a:ext cx="1325880" cy="329184"/>
+          </a:xfrm>
+          <a:prstGeom prst="rect">
+            <a:avLst/>
+          </a:prstGeom>
+          <a:noFill/>
+        </p:spPr>
+        <p:txBody>
+          <a:bodyPr wrap="square">
+            <a:spAutoFit/>
+          </a:bodyPr>
+          <a:lstStyle/>
+          <a:p>
+            <a:pPr>
+              <a:defRPr sz="1500" b="1">
+                <a:solidFill>
+                  <a:srgbClr val="5BCCE6"/>
+                </a:solidFill>
+              </a:defRPr>
+            </a:pPr>
+            <a:r>
+              <a:t>SSE</a:t>
+            </a:r>
+          </a:p>
+        </p:txBody>
+      </p:sp>
+      <p:sp>
+        <p:nvSpPr>
+          <p:cNvPr id="7" name="TextBox 6"/>
+          <p:cNvSpPr txBox="1"/>
+          <p:nvPr/>
+        </p:nvSpPr>
+        <p:spPr>
+          <a:xfrm>
+            <a:off x="6446520" y="2057400"/>
+            <a:ext cx="1005840" cy="329184"/>
+          </a:xfrm>
+          <a:prstGeom prst="rect">
+            <a:avLst/>
+          </a:prstGeom>
+          <a:noFill/>
+        </p:spPr>
+        <p:txBody>
+          <a:bodyPr wrap="square">
+            <a:spAutoFit/>
+          </a:bodyPr>
+          <a:lstStyle/>
+          <a:p>
+            <a:pPr>
+              <a:defRPr sz="1500" b="1">
+                <a:solidFill>
+                  <a:srgbClr val="5BCCE6"/>
+                </a:solidFill>
+              </a:defRPr>
+            </a:pPr>
+            <a:r>
+              <a:t>Purity</a:t>
+            </a:r>
+          </a:p>
+        </p:txBody>
+      </p:sp>
+      <p:sp>
+        <p:nvSpPr>
+          <p:cNvPr id="8" name="TextBox 7"/>
+          <p:cNvSpPr txBox="1"/>
+          <p:nvPr/>
+        </p:nvSpPr>
+        <p:spPr>
+          <a:xfrm>
+            <a:off x="7772400" y="2057400"/>
+            <a:ext cx="914400" cy="329184"/>
+          </a:xfrm>
+          <a:prstGeom prst="rect">
+            <a:avLst/>
+          </a:prstGeom>
+          <a:noFill/>
+        </p:spPr>
+        <p:txBody>
+          <a:bodyPr wrap="square">
+            <a:spAutoFit/>
+          </a:bodyPr>
+          <a:lstStyle/>
+          <a:p>
+            <a:pPr>
+              <a:defRPr sz="1500" b="1">
+                <a:solidFill>
+                  <a:srgbClr val="5BCCE6"/>
+                </a:solidFill>
+              </a:defRPr>
+            </a:pPr>
+            <a:r>
+              <a:t>ARI</a:t>
+            </a:r>
+          </a:p>
+        </p:txBody>
+      </p:sp>
+      <p:sp>
+        <p:nvSpPr>
+          <p:cNvPr id="9" name="TextBox 8"/>
+          <p:cNvSpPr txBox="1"/>
+          <p:nvPr/>
+        </p:nvSpPr>
+        <p:spPr>
+          <a:xfrm>
+            <a:off x="8997696" y="2057400"/>
+            <a:ext cx="914400" cy="329184"/>
+          </a:xfrm>
+          <a:prstGeom prst="rect">
+            <a:avLst/>
+          </a:prstGeom>
+          <a:noFill/>
+        </p:spPr>
+        <p:txBody>
+          <a:bodyPr wrap="square">
+            <a:spAutoFit/>
+          </a:bodyPr>
+          <a:lstStyle/>
+          <a:p>
+            <a:pPr>
+              <a:defRPr sz="1500" b="1">
+                <a:solidFill>
+                  <a:srgbClr val="5BCCE6"/>
+                </a:solidFill>
+              </a:defRPr>
+            </a:pPr>
+            <a:r>
+              <a:t>NMI</a:t>
+            </a:r>
+          </a:p>
+        </p:txBody>
+      </p:sp>
+      <p:sp>
+        <p:nvSpPr>
+          <p:cNvPr id="10" name="TextBox 9"/>
+          <p:cNvSpPr txBox="1"/>
+          <p:nvPr/>
+        </p:nvSpPr>
+        <p:spPr>
+          <a:xfrm>
+            <a:off x="594360" y="2496312"/>
+            <a:ext cx="3977639" cy="384048"/>
+          </a:xfrm>
+          <a:prstGeom prst="rect">
+            <a:avLst/>
+          </a:prstGeom>
+          <a:noFill/>
+        </p:spPr>
+        <p:txBody>
+          <a:bodyPr wrap="square">
+            <a:spAutoFit/>
+          </a:bodyPr>
+          <a:lstStyle/>
+          <a:p>
+            <a:pPr>
+              <a:defRPr sz="1400" b="0">
+                <a:solidFill>
+                  <a:srgbClr val="EBF2FA"/>
+                </a:solidFill>
+              </a:defRPr>
+            </a:pPr>
+            <a:r>
+              <a:t>Synthetic • Traditional</a:t>
+            </a:r>
+          </a:p>
+        </p:txBody>
+      </p:sp>
+      <p:sp>
+        <p:nvSpPr>
+          <p:cNvPr id="11" name="TextBox 10"/>
+          <p:cNvSpPr txBox="1"/>
+          <p:nvPr/>
+        </p:nvSpPr>
+        <p:spPr>
+          <a:xfrm>
+            <a:off x="4736592" y="2496312"/>
+            <a:ext cx="1325880" cy="384048"/>
+          </a:xfrm>
+          <a:prstGeom prst="rect">
+            <a:avLst/>
+          </a:prstGeom>
+          <a:noFill/>
+        </p:spPr>
+        <p:txBody>
+          <a:bodyPr wrap="square">
+            <a:spAutoFit/>
+          </a:bodyPr>
+          <a:lstStyle/>
+          <a:p>
+            <a:pPr>
+              <a:defRPr sz="1400" b="0">
+                <a:solidFill>
+                  <a:srgbClr val="EBF2FA"/>
+                </a:solidFill>
+              </a:defRPr>
+            </a:pPr>
+            <a:r>
+              <a:t>1,032.370</a:t>
+            </a:r>
+          </a:p>
+        </p:txBody>
+      </p:sp>
+      <p:sp>
+        <p:nvSpPr>
+          <p:cNvPr id="12" name="TextBox 11"/>
+          <p:cNvSpPr txBox="1"/>
+          <p:nvPr/>
+        </p:nvSpPr>
+        <p:spPr>
+          <a:xfrm>
+            <a:off x="6446520" y="2496312"/>
+            <a:ext cx="1005840" cy="384048"/>
+          </a:xfrm>
+          <a:prstGeom prst="rect">
+            <a:avLst/>
+          </a:prstGeom>
+          <a:noFill/>
+        </p:spPr>
+        <p:txBody>
+          <a:bodyPr wrap="square">
+            <a:spAutoFit/>
+          </a:bodyPr>
+          <a:lstStyle/>
+          <a:p>
+            <a:pPr>
+              <a:defRPr sz="1400" b="0">
+                <a:solidFill>
+                  <a:srgbClr val="EBF2FA"/>
+                </a:solidFill>
+              </a:defRPr>
+            </a:pPr>
+            <a:r>
+              <a:t>1.000</a:t>
+            </a:r>
+          </a:p>
+        </p:txBody>
+      </p:sp>
+      <p:sp>
+        <p:nvSpPr>
+          <p:cNvPr id="13" name="TextBox 12"/>
+          <p:cNvSpPr txBox="1"/>
+          <p:nvPr/>
+        </p:nvSpPr>
+        <p:spPr>
+          <a:xfrm>
+            <a:off x="7772400" y="2496312"/>
+            <a:ext cx="914400" cy="384048"/>
+          </a:xfrm>
+          <a:prstGeom prst="rect">
+            <a:avLst/>
+          </a:prstGeom>
+          <a:noFill/>
+        </p:spPr>
+        <p:txBody>
+          <a:bodyPr wrap="square">
+            <a:spAutoFit/>
+          </a:bodyPr>
+          <a:lstStyle/>
+          <a:p>
+            <a:pPr>
+              <a:defRPr sz="1400" b="0">
+                <a:solidFill>
+                  <a:srgbClr val="EBF2FA"/>
+                </a:solidFill>
+              </a:defRPr>
+            </a:pPr>
+            <a:r>
+              <a:t>1.000</a:t>
+            </a:r>
+          </a:p>
+        </p:txBody>
+      </p:sp>
+      <p:sp>
+        <p:nvSpPr>
+          <p:cNvPr id="14" name="TextBox 13"/>
+          <p:cNvSpPr txBox="1"/>
+          <p:nvPr/>
+        </p:nvSpPr>
+        <p:spPr>
+          <a:xfrm>
+            <a:off x="8997696" y="2496312"/>
+            <a:ext cx="914400" cy="384048"/>
+          </a:xfrm>
+          <a:prstGeom prst="rect">
+            <a:avLst/>
+          </a:prstGeom>
+          <a:noFill/>
+        </p:spPr>
+        <p:txBody>
+          <a:bodyPr wrap="square">
+            <a:spAutoFit/>
+          </a:bodyPr>
+          <a:lstStyle/>
+          <a:p>
+            <a:pPr>
+              <a:defRPr sz="1400" b="0">
+                <a:solidFill>
+                  <a:srgbClr val="EBF2FA"/>
+                </a:solidFill>
+              </a:defRPr>
+            </a:pPr>
+            <a:r>
+              <a:t>1.000</a:t>
+            </a:r>
+          </a:p>
+        </p:txBody>
+      </p:sp>
+      <p:sp>
+        <p:nvSpPr>
+          <p:cNvPr id="15" name="TextBox 14"/>
+          <p:cNvSpPr txBox="1"/>
+          <p:nvPr/>
+        </p:nvSpPr>
+        <p:spPr>
+          <a:xfrm>
+            <a:off x="594360" y="2935224"/>
+            <a:ext cx="3977639" cy="384048"/>
+          </a:xfrm>
+          <a:prstGeom prst="rect">
+            <a:avLst/>
+          </a:prstGeom>
+          <a:noFill/>
+        </p:spPr>
+        <p:txBody>
+          <a:bodyPr wrap="square">
+            <a:spAutoFit/>
+          </a:bodyPr>
+          <a:lstStyle/>
+          <a:p>
+            <a:pPr>
+              <a:defRPr sz="1400" b="0">
+                <a:solidFill>
+                  <a:srgbClr val="EBF2FA"/>
+                </a:solidFill>
+              </a:defRPr>
+            </a:pPr>
+            <a:r>
+              <a:t>Synthetic • Spark local[1]/[2]</a:t>
+            </a:r>
+          </a:p>
+        </p:txBody>
+      </p:sp>
+      <p:sp>
+        <p:nvSpPr>
+          <p:cNvPr id="16" name="TextBox 15"/>
+          <p:cNvSpPr txBox="1"/>
+          <p:nvPr/>
+        </p:nvSpPr>
+        <p:spPr>
+          <a:xfrm>
+            <a:off x="4736592" y="2935224"/>
+            <a:ext cx="1325880" cy="384048"/>
+          </a:xfrm>
+          <a:prstGeom prst="rect">
+            <a:avLst/>
+          </a:prstGeom>
+          <a:noFill/>
+        </p:spPr>
+        <p:txBody>
+          <a:bodyPr wrap="square">
+            <a:spAutoFit/>
+          </a:bodyPr>
+          <a:lstStyle/>
+          <a:p>
+            <a:pPr>
+              <a:defRPr sz="1400" b="0">
+                <a:solidFill>
+                  <a:srgbClr val="EBF2FA"/>
+                </a:solidFill>
+              </a:defRPr>
+            </a:pPr>
+            <a:r>
+              <a:t>1,032.370</a:t>
+            </a:r>
+          </a:p>
+        </p:txBody>
+      </p:sp>
+      <p:sp>
+        <p:nvSpPr>
+          <p:cNvPr id="17" name="TextBox 16"/>
+          <p:cNvSpPr txBox="1"/>
+          <p:nvPr/>
+        </p:nvSpPr>
+        <p:spPr>
+          <a:xfrm>
+            <a:off x="6446520" y="2935224"/>
+            <a:ext cx="1005840" cy="384048"/>
+          </a:xfrm>
+          <a:prstGeom prst="rect">
+            <a:avLst/>
+          </a:prstGeom>
+          <a:noFill/>
+        </p:spPr>
+        <p:txBody>
+          <a:bodyPr wrap="square">
+            <a:spAutoFit/>
+          </a:bodyPr>
+          <a:lstStyle/>
+          <a:p>
+            <a:pPr>
+              <a:defRPr sz="1400" b="0">
+                <a:solidFill>
+                  <a:srgbClr val="EBF2FA"/>
+                </a:solidFill>
+              </a:defRPr>
+            </a:pPr>
+            <a:r>
+              <a:t>1.000</a:t>
+            </a:r>
+          </a:p>
+        </p:txBody>
+      </p:sp>
+      <p:sp>
+        <p:nvSpPr>
+          <p:cNvPr id="18" name="TextBox 17"/>
+          <p:cNvSpPr txBox="1"/>
+          <p:nvPr/>
+        </p:nvSpPr>
+        <p:spPr>
+          <a:xfrm>
+            <a:off x="7772400" y="2935224"/>
+            <a:ext cx="914400" cy="384048"/>
+          </a:xfrm>
+          <a:prstGeom prst="rect">
+            <a:avLst/>
+          </a:prstGeom>
+          <a:noFill/>
+        </p:spPr>
+        <p:txBody>
+          <a:bodyPr wrap="square">
+            <a:spAutoFit/>
+          </a:bodyPr>
+          <a:lstStyle/>
+          <a:p>
+            <a:pPr>
+              <a:defRPr sz="1400" b="0">
+                <a:solidFill>
+                  <a:srgbClr val="EBF2FA"/>
+                </a:solidFill>
+              </a:defRPr>
+            </a:pPr>
+            <a:r>
+              <a:t>1.000</a:t>
+            </a:r>
+          </a:p>
+        </p:txBody>
+      </p:sp>
+      <p:sp>
+        <p:nvSpPr>
+          <p:cNvPr id="19" name="TextBox 18"/>
+          <p:cNvSpPr txBox="1"/>
+          <p:nvPr/>
+        </p:nvSpPr>
+        <p:spPr>
+          <a:xfrm>
+            <a:off x="8997696" y="2935224"/>
+            <a:ext cx="914400" cy="384048"/>
+          </a:xfrm>
+          <a:prstGeom prst="rect">
+            <a:avLst/>
+          </a:prstGeom>
+          <a:noFill/>
+        </p:spPr>
+        <p:txBody>
+          <a:bodyPr wrap="square">
+            <a:spAutoFit/>
+          </a:bodyPr>
+          <a:lstStyle/>
+          <a:p>
+            <a:pPr>
+              <a:defRPr sz="1400" b="0">
+                <a:solidFill>
+                  <a:srgbClr val="EBF2FA"/>
+                </a:solidFill>
+              </a:defRPr>
+            </a:pPr>
+            <a:r>
+              <a:t>1.000</a:t>
+            </a:r>
+          </a:p>
+        </p:txBody>
+      </p:sp>
+      <p:sp>
+        <p:nvSpPr>
+          <p:cNvPr id="20" name="TextBox 19"/>
+          <p:cNvSpPr txBox="1"/>
+          <p:nvPr/>
+        </p:nvSpPr>
+        <p:spPr>
+          <a:xfrm>
+            <a:off x="594360" y="3374136"/>
+            <a:ext cx="3977639" cy="384048"/>
+          </a:xfrm>
+          <a:prstGeom prst="rect">
+            <a:avLst/>
+          </a:prstGeom>
+          <a:noFill/>
+        </p:spPr>
+        <p:txBody>
+          <a:bodyPr wrap="square">
+            <a:spAutoFit/>
+          </a:bodyPr>
+          <a:lstStyle/>
+          <a:p>
+            <a:pPr>
+              <a:defRPr sz="1400" b="0">
+                <a:solidFill>
+                  <a:srgbClr val="EBF2FA"/>
+                </a:solidFill>
+              </a:defRPr>
+            </a:pPr>
+            <a:r>
+              <a:t>KDD99 • Traditional</a:t>
+            </a:r>
+          </a:p>
+        </p:txBody>
+      </p:sp>
+      <p:sp>
+        <p:nvSpPr>
+          <p:cNvPr id="21" name="TextBox 20"/>
+          <p:cNvSpPr txBox="1"/>
+          <p:nvPr/>
+        </p:nvSpPr>
+        <p:spPr>
+          <a:xfrm>
+            <a:off x="4736592" y="3374136"/>
+            <a:ext cx="1325880" cy="384048"/>
+          </a:xfrm>
+          <a:prstGeom prst="rect">
+            <a:avLst/>
+          </a:prstGeom>
+          <a:noFill/>
+        </p:spPr>
+        <p:txBody>
+          <a:bodyPr wrap="square">
+            <a:spAutoFit/>
+          </a:bodyPr>
+          <a:lstStyle/>
+          <a:p>
+            <a:pPr>
+              <a:defRPr sz="1400" b="0">
+                <a:solidFill>
+                  <a:srgbClr val="EBF2FA"/>
+                </a:solidFill>
+              </a:defRPr>
+            </a:pPr>
+            <a:r>
+              <a:t>9,342.830</a:t>
+            </a:r>
+          </a:p>
+        </p:txBody>
+      </p:sp>
+      <p:sp>
+        <p:nvSpPr>
+          <p:cNvPr id="22" name="TextBox 21"/>
+          <p:cNvSpPr txBox="1"/>
+          <p:nvPr/>
+        </p:nvSpPr>
+        <p:spPr>
+          <a:xfrm>
+            <a:off x="6446520" y="3374136"/>
+            <a:ext cx="1005840" cy="384048"/>
+          </a:xfrm>
+          <a:prstGeom prst="rect">
+            <a:avLst/>
+          </a:prstGeom>
+          <a:noFill/>
+        </p:spPr>
+        <p:txBody>
+          <a:bodyPr wrap="square">
+            <a:spAutoFit/>
+          </a:bodyPr>
+          <a:lstStyle/>
+          <a:p>
+            <a:pPr>
+              <a:defRPr sz="1400" b="0">
+                <a:solidFill>
+                  <a:srgbClr val="EBF2FA"/>
+                </a:solidFill>
+              </a:defRPr>
+            </a:pPr>
+            <a:r>
+              <a:t>0.975</a:t>
+            </a:r>
+          </a:p>
+        </p:txBody>
+      </p:sp>
+      <p:sp>
+        <p:nvSpPr>
+          <p:cNvPr id="23" name="TextBox 22"/>
+          <p:cNvSpPr txBox="1"/>
+          <p:nvPr/>
+        </p:nvSpPr>
+        <p:spPr>
+          <a:xfrm>
+            <a:off x="7772400" y="3374136"/>
+            <a:ext cx="914400" cy="384048"/>
+          </a:xfrm>
+          <a:prstGeom prst="rect">
+            <a:avLst/>
+          </a:prstGeom>
+          <a:noFill/>
+        </p:spPr>
+        <p:txBody>
+          <a:bodyPr wrap="square">
+            <a:spAutoFit/>
+          </a:bodyPr>
+          <a:lstStyle/>
+          <a:p>
+            <a:pPr>
+              <a:defRPr sz="1400" b="0">
+                <a:solidFill>
+                  <a:srgbClr val="EBF2FA"/>
+                </a:solidFill>
+              </a:defRPr>
+            </a:pPr>
+            <a:r>
+              <a:t>0.432</a:t>
+            </a:r>
+          </a:p>
+        </p:txBody>
+      </p:sp>
+      <p:sp>
+        <p:nvSpPr>
+          <p:cNvPr id="24" name="TextBox 23"/>
+          <p:cNvSpPr txBox="1"/>
+          <p:nvPr/>
+        </p:nvSpPr>
+        <p:spPr>
+          <a:xfrm>
+            <a:off x="8997696" y="3374136"/>
+            <a:ext cx="914400" cy="384048"/>
+          </a:xfrm>
+          <a:prstGeom prst="rect">
+            <a:avLst/>
+          </a:prstGeom>
+          <a:noFill/>
+        </p:spPr>
+        <p:txBody>
+          <a:bodyPr wrap="square">
+            <a:spAutoFit/>
+          </a:bodyPr>
+          <a:lstStyle/>
+          <a:p>
+            <a:pPr>
+              <a:defRPr sz="1400" b="0">
+                <a:solidFill>
+                  <a:srgbClr val="EBF2FA"/>
+                </a:solidFill>
+              </a:defRPr>
+            </a:pPr>
+            <a:r>
+              <a:t>0.535</a:t>
+            </a:r>
+          </a:p>
+        </p:txBody>
+      </p:sp>
+      <p:sp>
+        <p:nvSpPr>
+          <p:cNvPr id="25" name="TextBox 24"/>
+          <p:cNvSpPr txBox="1"/>
+          <p:nvPr/>
+        </p:nvSpPr>
+        <p:spPr>
+          <a:xfrm>
+            <a:off x="594360" y="3813048"/>
+            <a:ext cx="3977639" cy="384048"/>
+          </a:xfrm>
+          <a:prstGeom prst="rect">
+            <a:avLst/>
+          </a:prstGeom>
+          <a:noFill/>
+        </p:spPr>
+        <p:txBody>
+          <a:bodyPr wrap="square">
+            <a:spAutoFit/>
+          </a:bodyPr>
+          <a:lstStyle/>
+          <a:p>
+            <a:pPr>
+              <a:defRPr sz="1400" b="0">
+                <a:solidFill>
+                  <a:srgbClr val="EBF2FA"/>
+                </a:solidFill>
+              </a:defRPr>
+            </a:pPr>
+            <a:r>
+              <a:t>KDD99 • Spark local[1]/[2]</a:t>
+            </a:r>
+          </a:p>
+        </p:txBody>
+      </p:sp>
+      <p:sp>
+        <p:nvSpPr>
+          <p:cNvPr id="26" name="TextBox 25"/>
+          <p:cNvSpPr txBox="1"/>
+          <p:nvPr/>
+        </p:nvSpPr>
+        <p:spPr>
+          <a:xfrm>
+            <a:off x="4736592" y="3813048"/>
+            <a:ext cx="1325880" cy="384048"/>
+          </a:xfrm>
+          <a:prstGeom prst="rect">
+            <a:avLst/>
+          </a:prstGeom>
+          <a:noFill/>
+        </p:spPr>
+        <p:txBody>
+          <a:bodyPr wrap="square">
+            <a:spAutoFit/>
+          </a:bodyPr>
+          <a:lstStyle/>
+          <a:p>
+            <a:pPr>
+              <a:defRPr sz="1400" b="0">
+                <a:solidFill>
+                  <a:srgbClr val="EBF2FA"/>
+                </a:solidFill>
+              </a:defRPr>
+            </a:pPr>
+            <a:r>
+              <a:t>21,072.555</a:t>
+            </a:r>
+          </a:p>
+        </p:txBody>
+      </p:sp>
+      <p:sp>
+        <p:nvSpPr>
+          <p:cNvPr id="27" name="TextBox 26"/>
+          <p:cNvSpPr txBox="1"/>
+          <p:nvPr/>
+        </p:nvSpPr>
+        <p:spPr>
+          <a:xfrm>
+            <a:off x="6446520" y="3813048"/>
+            <a:ext cx="1005840" cy="384048"/>
+          </a:xfrm>
+          <a:prstGeom prst="rect">
+            <a:avLst/>
+          </a:prstGeom>
+          <a:noFill/>
+        </p:spPr>
+        <p:txBody>
+          <a:bodyPr wrap="square">
+            <a:spAutoFit/>
+          </a:bodyPr>
+          <a:lstStyle/>
+          <a:p>
+            <a:pPr>
+              <a:defRPr sz="1400" b="0">
+                <a:solidFill>
+                  <a:srgbClr val="EBF2FA"/>
+                </a:solidFill>
+              </a:defRPr>
+            </a:pPr>
+            <a:r>
+              <a:t>0.797</a:t>
+            </a:r>
+          </a:p>
+        </p:txBody>
+      </p:sp>
+      <p:sp>
+        <p:nvSpPr>
+          <p:cNvPr id="28" name="TextBox 27"/>
+          <p:cNvSpPr txBox="1"/>
+          <p:nvPr/>
+        </p:nvSpPr>
+        <p:spPr>
+          <a:xfrm>
+            <a:off x="7772400" y="3813048"/>
+            <a:ext cx="914400" cy="384048"/>
+          </a:xfrm>
+          <a:prstGeom prst="rect">
+            <a:avLst/>
+          </a:prstGeom>
+          <a:noFill/>
+        </p:spPr>
+        <p:txBody>
+          <a:bodyPr wrap="square">
+            <a:spAutoFit/>
+          </a:bodyPr>
+          <a:lstStyle/>
+          <a:p>
+            <a:pPr>
+              <a:defRPr sz="1400" b="0">
+                <a:solidFill>
+                  <a:srgbClr val="EBF2FA"/>
+                </a:solidFill>
+              </a:defRPr>
+            </a:pPr>
+            <a:r>
+              <a:t>-0.005</a:t>
+            </a:r>
+          </a:p>
+        </p:txBody>
+      </p:sp>
+      <p:sp>
+        <p:nvSpPr>
+          <p:cNvPr id="29" name="TextBox 28"/>
+          <p:cNvSpPr txBox="1"/>
+          <p:nvPr/>
+        </p:nvSpPr>
+        <p:spPr>
+          <a:xfrm>
+            <a:off x="8997696" y="3813048"/>
+            <a:ext cx="914400" cy="384048"/>
+          </a:xfrm>
+          <a:prstGeom prst="rect">
+            <a:avLst/>
+          </a:prstGeom>
+          <a:noFill/>
+        </p:spPr>
+        <p:txBody>
+          <a:bodyPr wrap="square">
+            <a:spAutoFit/>
+          </a:bodyPr>
+          <a:lstStyle/>
+          <a:p>
+            <a:pPr>
+              <a:defRPr sz="1400" b="0">
+                <a:solidFill>
+                  <a:srgbClr val="EBF2FA"/>
+                </a:solidFill>
+              </a:defRPr>
+            </a:pPr>
+            <a:r>
+              <a:t>0.011</a:t>
+            </a:r>
+          </a:p>
+        </p:txBody>
+      </p:sp>
+      <p:sp>
+        <p:nvSpPr>
+          <p:cNvPr id="30" name="TextBox 29"/>
+          <p:cNvSpPr txBox="1"/>
+          <p:nvPr/>
+        </p:nvSpPr>
+        <p:spPr>
+          <a:xfrm>
+            <a:off x="594360" y="4498848"/>
+            <a:ext cx="11094720" cy="411480"/>
+          </a:xfrm>
+          <a:prstGeom prst="rect">
+            <a:avLst/>
+          </a:prstGeom>
+          <a:noFill/>
+        </p:spPr>
+        <p:txBody>
+          <a:bodyPr wrap="square">
+            <a:spAutoFit/>
+          </a:bodyPr>
+          <a:lstStyle/>
+          <a:p>
+            <a:pPr>
+              <a:defRPr sz="1500" b="1">
+                <a:solidFill>
+                  <a:srgbClr val="5BCCE6"/>
+                </a:solidFill>
+              </a:defRPr>
+            </a:pPr>
+            <a:r>
+              <a:t>All four Spark runs passed independent SSE, assignment, and cluster-count checks.</a:t>
+            </a:r>
+          </a:p>
+        </p:txBody>
+      </p:sp>
+      <p:sp>
+        <p:nvSpPr>
+          <p:cNvPr id="31" name="TextBox 30"/>
+          <p:cNvSpPr txBox="1"/>
+          <p:nvPr/>
+        </p:nvSpPr>
+        <p:spPr>
+          <a:xfrm>
+            <a:off x="594360" y="5010912"/>
+            <a:ext cx="11094720" cy="960120"/>
+          </a:xfrm>
+          <a:prstGeom prst="rect">
+            <a:avLst/>
+          </a:prstGeom>
+          <a:noFill/>
+        </p:spPr>
+        <p:txBody>
+          <a:bodyPr wrap="square">
+            <a:spAutoFit/>
+          </a:bodyPr>
+          <a:lstStyle/>
+          <a:p>
+            <a:pPr>
+              <a:defRPr sz="1400" b="0">
+                <a:solidFill>
+                  <a:srgbClr val="EBF2FA"/>
+                </a:solidFill>
+              </a:defRPr>
+            </a:pPr>
+            <a:r>
+              <a:t>KDD99 purity 0.797 is near the 0.795 majority-class reference. This five-cluster check is separate from the earlier four-cluster, 42-run controlled study. Spark local[n] uses one computer.</a:t>
             </a:r>
           </a:p>
         </p:txBody>

</xml_diff>

<commit_message>
Install final audited K-Means report and presentation
</commit_message>
<xml_diff>
--- a/docs/final_submission/Group7_Parallel_KMeans_Final_Presentation.pptx
+++ b/docs/final_submission/Group7_Parallel_KMeans_Final_Presentation.pptx
@@ -4566,7 +4566,7 @@
           <a:lstStyle/>
           <a:p>
             <a:r>
-              <a:t>01 / 23</a:t>
+              <a:t>01 / 24</a:t>
             </a:r>
           </a:p>
         </p:txBody>
@@ -5492,7 +5492,7 @@
               </a:defRPr>
             </a:pPr>
             <a:r>
-              <a:t>10 / 23</a:t>
+              <a:t>10 / 24</a:t>
             </a:r>
           </a:p>
         </p:txBody>
@@ -6255,7 +6255,7 @@
               </a:defRPr>
             </a:pPr>
             <a:r>
-              <a:t>11 / 23</a:t>
+              <a:t>11 / 24</a:t>
             </a:r>
           </a:p>
         </p:txBody>
@@ -6864,7 +6864,7 @@
               </a:defRPr>
             </a:pPr>
             <a:r>
-              <a:t>12 / 23</a:t>
+              <a:t>12 / 24</a:t>
             </a:r>
           </a:p>
         </p:txBody>
@@ -7169,7 +7169,7 @@
           <a:lstStyle/>
           <a:p>
             <a:r>
-              <a:t>13 / 23</a:t>
+              <a:t>13 / 24</a:t>
             </a:r>
           </a:p>
         </p:txBody>
@@ -7585,7 +7585,7 @@
           <a:lstStyle/>
           <a:p>
             <a:r>
-              <a:t>14 / 23</a:t>
+              <a:t>14 / 24</a:t>
             </a:r>
           </a:p>
         </p:txBody>
@@ -8001,7 +8001,7 @@
           <a:lstStyle/>
           <a:p>
             <a:r>
-              <a:t>15 / 23</a:t>
+              <a:t>15 / 24</a:t>
             </a:r>
           </a:p>
         </p:txBody>
@@ -8875,7 +8875,7 @@
               </a:defRPr>
             </a:pPr>
             <a:r>
-              <a:t>16 / 23</a:t>
+              <a:t>16 / 24</a:t>
             </a:r>
           </a:p>
         </p:txBody>
@@ -9180,7 +9180,7 @@
           <a:lstStyle/>
           <a:p>
             <a:r>
-              <a:t>17 / 23</a:t>
+              <a:t>17 / 24</a:t>
             </a:r>
           </a:p>
         </p:txBody>
@@ -9596,7 +9596,7 @@
           <a:lstStyle/>
           <a:p>
             <a:r>
-              <a:t>18 / 23</a:t>
+              <a:t>18 / 24</a:t>
             </a:r>
           </a:p>
         </p:txBody>
@@ -11218,7 +11218,7 @@
           <a:lstStyle/>
           <a:p>
             <a:r>
-              <a:t>19 / 23</a:t>
+              <a:t>19 / 24</a:t>
             </a:r>
           </a:p>
         </p:txBody>
@@ -12118,7 +12118,7 @@
           <a:lstStyle/>
           <a:p>
             <a:r>
-              <a:t>02 / 23</a:t>
+              <a:t>02 / 24</a:t>
             </a:r>
           </a:p>
         </p:txBody>
@@ -13391,7 +13391,7 @@
               </a:defRPr>
             </a:pPr>
             <a:r>
-              <a:t>20 / 23</a:t>
+              <a:t>20 / 24</a:t>
             </a:r>
           </a:p>
         </p:txBody>
@@ -13646,7 +13646,7 @@
           <a:lstStyle/>
           <a:p>
             <a:r>
-              <a:t>21 / 23</a:t>
+              <a:t>21 / 24</a:t>
             </a:r>
           </a:p>
         </p:txBody>
@@ -15116,7 +15116,7 @@
               </a:defRPr>
             </a:pPr>
             <a:r>
-              <a:t>22 / 23</a:t>
+              <a:t>22 / 24</a:t>
             </a:r>
           </a:p>
         </p:txBody>
@@ -15130,6 +15130,1154 @@
 </file>
 
 <file path=ppt/slides/slide23.xml><?xml version="1.0" encoding="utf-8"?>
+<p:sld xmlns:a="http://schemas.openxmlformats.org/drawingml/2006/main" xmlns:p="http://schemas.openxmlformats.org/presentationml/2006/main" xmlns:r="http://schemas.openxmlformats.org/officeDocument/2006/relationships">
+  <p:cSld>
+    <p:bg>
+      <p:bgPr>
+        <a:solidFill>
+          <a:srgbClr val="0D192D"/>
+        </a:solidFill>
+        <a:effectLst/>
+      </p:bgPr>
+    </p:bg>
+    <p:spTree>
+      <p:nvGrpSpPr>
+        <p:cNvPr id="1" name=""/>
+        <p:cNvGrpSpPr/>
+        <p:nvPr/>
+      </p:nvGrpSpPr>
+      <p:grpSpPr/>
+      <p:sp>
+        <p:nvSpPr>
+          <p:cNvPr id="2" name="TextBox 1"/>
+          <p:cNvSpPr txBox="1"/>
+          <p:nvPr/>
+        </p:nvSpPr>
+        <p:spPr>
+          <a:xfrm>
+            <a:off x="594360" y="347472"/>
+            <a:ext cx="11003280" cy="329184"/>
+          </a:xfrm>
+          <a:prstGeom prst="rect">
+            <a:avLst/>
+          </a:prstGeom>
+          <a:noFill/>
+        </p:spPr>
+        <p:txBody>
+          <a:bodyPr wrap="square">
+            <a:spAutoFit/>
+          </a:bodyPr>
+          <a:lstStyle/>
+          <a:p>
+            <a:pPr>
+              <a:defRPr sz="1400" b="1">
+                <a:solidFill>
+                  <a:srgbClr val="5BCCE6"/>
+                </a:solidFill>
+              </a:defRPr>
+            </a:pPr>
+            <a:r>
+              <a:t>SUPPLEMENTARY VERIFICATION</a:t>
+            </a:r>
+          </a:p>
+        </p:txBody>
+      </p:sp>
+      <p:sp>
+        <p:nvSpPr>
+          <p:cNvPr id="3" name="TextBox 2"/>
+          <p:cNvSpPr txBox="1"/>
+          <p:nvPr/>
+        </p:nvSpPr>
+        <p:spPr>
+          <a:xfrm>
+            <a:off x="594360" y="822960"/>
+            <a:ext cx="11094720" cy="640080"/>
+          </a:xfrm>
+          <a:prstGeom prst="rect">
+            <a:avLst/>
+          </a:prstGeom>
+          <a:noFill/>
+        </p:spPr>
+        <p:txBody>
+          <a:bodyPr wrap="square">
+            <a:spAutoFit/>
+          </a:bodyPr>
+          <a:lstStyle/>
+          <a:p>
+            <a:pPr>
+              <a:defRPr sz="2700" b="1">
+                <a:solidFill>
+                  <a:srgbClr val="EBF2FA"/>
+                </a:solidFill>
+              </a:defRPr>
+            </a:pPr>
+            <a:r>
+              <a:t>Independent SSE &amp; cluster-quality checks</a:t>
+            </a:r>
+          </a:p>
+        </p:txBody>
+      </p:sp>
+      <p:sp>
+        <p:nvSpPr>
+          <p:cNvPr id="4" name="TextBox 3"/>
+          <p:cNvSpPr txBox="1"/>
+          <p:nvPr/>
+        </p:nvSpPr>
+        <p:spPr>
+          <a:xfrm>
+            <a:off x="594360" y="1527048"/>
+            <a:ext cx="11094720" cy="365760"/>
+          </a:xfrm>
+          <a:prstGeom prst="rect">
+            <a:avLst/>
+          </a:prstGeom>
+          <a:noFill/>
+        </p:spPr>
+        <p:txBody>
+          <a:bodyPr wrap="square">
+            <a:spAutoFit/>
+          </a:bodyPr>
+          <a:lstStyle/>
+          <a:p>
+            <a:pPr>
+              <a:defRPr sz="1600" b="0">
+                <a:solidFill>
+                  <a:srgbClr val="EBF2FA"/>
+                </a:solidFill>
+              </a:defRPr>
+            </a:pPr>
+            <a:r>
+              <a:t>1,000 records  •  2 partitions  •  seed 42  •  5 clusters</a:t>
+            </a:r>
+          </a:p>
+        </p:txBody>
+      </p:sp>
+      <p:sp>
+        <p:nvSpPr>
+          <p:cNvPr id="5" name="TextBox 4"/>
+          <p:cNvSpPr txBox="1"/>
+          <p:nvPr/>
+        </p:nvSpPr>
+        <p:spPr>
+          <a:xfrm>
+            <a:off x="594360" y="2057400"/>
+            <a:ext cx="3977639" cy="329184"/>
+          </a:xfrm>
+          <a:prstGeom prst="rect">
+            <a:avLst/>
+          </a:prstGeom>
+          <a:noFill/>
+        </p:spPr>
+        <p:txBody>
+          <a:bodyPr wrap="square">
+            <a:spAutoFit/>
+          </a:bodyPr>
+          <a:lstStyle/>
+          <a:p>
+            <a:pPr>
+              <a:defRPr sz="1500" b="1">
+                <a:solidFill>
+                  <a:srgbClr val="5BCCE6"/>
+                </a:solidFill>
+              </a:defRPr>
+            </a:pPr>
+            <a:r>
+              <a:t>Dataset / method</a:t>
+            </a:r>
+          </a:p>
+        </p:txBody>
+      </p:sp>
+      <p:sp>
+        <p:nvSpPr>
+          <p:cNvPr id="6" name="TextBox 5"/>
+          <p:cNvSpPr txBox="1"/>
+          <p:nvPr/>
+        </p:nvSpPr>
+        <p:spPr>
+          <a:xfrm>
+            <a:off x="4736592" y="2057400"/>
+            <a:ext cx="1325880" cy="329184"/>
+          </a:xfrm>
+          <a:prstGeom prst="rect">
+            <a:avLst/>
+          </a:prstGeom>
+          <a:noFill/>
+        </p:spPr>
+        <p:txBody>
+          <a:bodyPr wrap="square">
+            <a:spAutoFit/>
+          </a:bodyPr>
+          <a:lstStyle/>
+          <a:p>
+            <a:pPr>
+              <a:defRPr sz="1500" b="1">
+                <a:solidFill>
+                  <a:srgbClr val="5BCCE6"/>
+                </a:solidFill>
+              </a:defRPr>
+            </a:pPr>
+            <a:r>
+              <a:t>SSE</a:t>
+            </a:r>
+          </a:p>
+        </p:txBody>
+      </p:sp>
+      <p:sp>
+        <p:nvSpPr>
+          <p:cNvPr id="7" name="TextBox 6"/>
+          <p:cNvSpPr txBox="1"/>
+          <p:nvPr/>
+        </p:nvSpPr>
+        <p:spPr>
+          <a:xfrm>
+            <a:off x="6446520" y="2057400"/>
+            <a:ext cx="1005840" cy="329184"/>
+          </a:xfrm>
+          <a:prstGeom prst="rect">
+            <a:avLst/>
+          </a:prstGeom>
+          <a:noFill/>
+        </p:spPr>
+        <p:txBody>
+          <a:bodyPr wrap="square">
+            <a:spAutoFit/>
+          </a:bodyPr>
+          <a:lstStyle/>
+          <a:p>
+            <a:pPr>
+              <a:defRPr sz="1500" b="1">
+                <a:solidFill>
+                  <a:srgbClr val="5BCCE6"/>
+                </a:solidFill>
+              </a:defRPr>
+            </a:pPr>
+            <a:r>
+              <a:t>Purity</a:t>
+            </a:r>
+          </a:p>
+        </p:txBody>
+      </p:sp>
+      <p:sp>
+        <p:nvSpPr>
+          <p:cNvPr id="8" name="TextBox 7"/>
+          <p:cNvSpPr txBox="1"/>
+          <p:nvPr/>
+        </p:nvSpPr>
+        <p:spPr>
+          <a:xfrm>
+            <a:off x="7772400" y="2057400"/>
+            <a:ext cx="914400" cy="329184"/>
+          </a:xfrm>
+          <a:prstGeom prst="rect">
+            <a:avLst/>
+          </a:prstGeom>
+          <a:noFill/>
+        </p:spPr>
+        <p:txBody>
+          <a:bodyPr wrap="square">
+            <a:spAutoFit/>
+          </a:bodyPr>
+          <a:lstStyle/>
+          <a:p>
+            <a:pPr>
+              <a:defRPr sz="1500" b="1">
+                <a:solidFill>
+                  <a:srgbClr val="5BCCE6"/>
+                </a:solidFill>
+              </a:defRPr>
+            </a:pPr>
+            <a:r>
+              <a:t>ARI</a:t>
+            </a:r>
+          </a:p>
+        </p:txBody>
+      </p:sp>
+      <p:sp>
+        <p:nvSpPr>
+          <p:cNvPr id="9" name="TextBox 8"/>
+          <p:cNvSpPr txBox="1"/>
+          <p:nvPr/>
+        </p:nvSpPr>
+        <p:spPr>
+          <a:xfrm>
+            <a:off x="8997696" y="2057400"/>
+            <a:ext cx="914400" cy="329184"/>
+          </a:xfrm>
+          <a:prstGeom prst="rect">
+            <a:avLst/>
+          </a:prstGeom>
+          <a:noFill/>
+        </p:spPr>
+        <p:txBody>
+          <a:bodyPr wrap="square">
+            <a:spAutoFit/>
+          </a:bodyPr>
+          <a:lstStyle/>
+          <a:p>
+            <a:pPr>
+              <a:defRPr sz="1500" b="1">
+                <a:solidFill>
+                  <a:srgbClr val="5BCCE6"/>
+                </a:solidFill>
+              </a:defRPr>
+            </a:pPr>
+            <a:r>
+              <a:t>NMI</a:t>
+            </a:r>
+          </a:p>
+        </p:txBody>
+      </p:sp>
+      <p:sp>
+        <p:nvSpPr>
+          <p:cNvPr id="10" name="TextBox 9"/>
+          <p:cNvSpPr txBox="1"/>
+          <p:nvPr/>
+        </p:nvSpPr>
+        <p:spPr>
+          <a:xfrm>
+            <a:off x="594360" y="2496312"/>
+            <a:ext cx="3977639" cy="384048"/>
+          </a:xfrm>
+          <a:prstGeom prst="rect">
+            <a:avLst/>
+          </a:prstGeom>
+          <a:noFill/>
+        </p:spPr>
+        <p:txBody>
+          <a:bodyPr wrap="square">
+            <a:spAutoFit/>
+          </a:bodyPr>
+          <a:lstStyle/>
+          <a:p>
+            <a:pPr>
+              <a:defRPr sz="1400" b="0">
+                <a:solidFill>
+                  <a:srgbClr val="EBF2FA"/>
+                </a:solidFill>
+              </a:defRPr>
+            </a:pPr>
+            <a:r>
+              <a:t>Synthetic • Traditional</a:t>
+            </a:r>
+          </a:p>
+        </p:txBody>
+      </p:sp>
+      <p:sp>
+        <p:nvSpPr>
+          <p:cNvPr id="11" name="TextBox 10"/>
+          <p:cNvSpPr txBox="1"/>
+          <p:nvPr/>
+        </p:nvSpPr>
+        <p:spPr>
+          <a:xfrm>
+            <a:off x="4736592" y="2496312"/>
+            <a:ext cx="1325880" cy="384048"/>
+          </a:xfrm>
+          <a:prstGeom prst="rect">
+            <a:avLst/>
+          </a:prstGeom>
+          <a:noFill/>
+        </p:spPr>
+        <p:txBody>
+          <a:bodyPr wrap="square">
+            <a:spAutoFit/>
+          </a:bodyPr>
+          <a:lstStyle/>
+          <a:p>
+            <a:pPr>
+              <a:defRPr sz="1400" b="0">
+                <a:solidFill>
+                  <a:srgbClr val="EBF2FA"/>
+                </a:solidFill>
+              </a:defRPr>
+            </a:pPr>
+            <a:r>
+              <a:t>1,032.370</a:t>
+            </a:r>
+          </a:p>
+        </p:txBody>
+      </p:sp>
+      <p:sp>
+        <p:nvSpPr>
+          <p:cNvPr id="12" name="TextBox 11"/>
+          <p:cNvSpPr txBox="1"/>
+          <p:nvPr/>
+        </p:nvSpPr>
+        <p:spPr>
+          <a:xfrm>
+            <a:off x="6446520" y="2496312"/>
+            <a:ext cx="1005840" cy="384048"/>
+          </a:xfrm>
+          <a:prstGeom prst="rect">
+            <a:avLst/>
+          </a:prstGeom>
+          <a:noFill/>
+        </p:spPr>
+        <p:txBody>
+          <a:bodyPr wrap="square">
+            <a:spAutoFit/>
+          </a:bodyPr>
+          <a:lstStyle/>
+          <a:p>
+            <a:pPr>
+              <a:defRPr sz="1400" b="0">
+                <a:solidFill>
+                  <a:srgbClr val="EBF2FA"/>
+                </a:solidFill>
+              </a:defRPr>
+            </a:pPr>
+            <a:r>
+              <a:t>1.000</a:t>
+            </a:r>
+          </a:p>
+        </p:txBody>
+      </p:sp>
+      <p:sp>
+        <p:nvSpPr>
+          <p:cNvPr id="13" name="TextBox 12"/>
+          <p:cNvSpPr txBox="1"/>
+          <p:nvPr/>
+        </p:nvSpPr>
+        <p:spPr>
+          <a:xfrm>
+            <a:off x="7772400" y="2496312"/>
+            <a:ext cx="914400" cy="384048"/>
+          </a:xfrm>
+          <a:prstGeom prst="rect">
+            <a:avLst/>
+          </a:prstGeom>
+          <a:noFill/>
+        </p:spPr>
+        <p:txBody>
+          <a:bodyPr wrap="square">
+            <a:spAutoFit/>
+          </a:bodyPr>
+          <a:lstStyle/>
+          <a:p>
+            <a:pPr>
+              <a:defRPr sz="1400" b="0">
+                <a:solidFill>
+                  <a:srgbClr val="EBF2FA"/>
+                </a:solidFill>
+              </a:defRPr>
+            </a:pPr>
+            <a:r>
+              <a:t>1.000</a:t>
+            </a:r>
+          </a:p>
+        </p:txBody>
+      </p:sp>
+      <p:sp>
+        <p:nvSpPr>
+          <p:cNvPr id="14" name="TextBox 13"/>
+          <p:cNvSpPr txBox="1"/>
+          <p:nvPr/>
+        </p:nvSpPr>
+        <p:spPr>
+          <a:xfrm>
+            <a:off x="8997696" y="2496312"/>
+            <a:ext cx="914400" cy="384048"/>
+          </a:xfrm>
+          <a:prstGeom prst="rect">
+            <a:avLst/>
+          </a:prstGeom>
+          <a:noFill/>
+        </p:spPr>
+        <p:txBody>
+          <a:bodyPr wrap="square">
+            <a:spAutoFit/>
+          </a:bodyPr>
+          <a:lstStyle/>
+          <a:p>
+            <a:pPr>
+              <a:defRPr sz="1400" b="0">
+                <a:solidFill>
+                  <a:srgbClr val="EBF2FA"/>
+                </a:solidFill>
+              </a:defRPr>
+            </a:pPr>
+            <a:r>
+              <a:t>1.000</a:t>
+            </a:r>
+          </a:p>
+        </p:txBody>
+      </p:sp>
+      <p:sp>
+        <p:nvSpPr>
+          <p:cNvPr id="15" name="TextBox 14"/>
+          <p:cNvSpPr txBox="1"/>
+          <p:nvPr/>
+        </p:nvSpPr>
+        <p:spPr>
+          <a:xfrm>
+            <a:off x="594360" y="2935224"/>
+            <a:ext cx="3977639" cy="384048"/>
+          </a:xfrm>
+          <a:prstGeom prst="rect">
+            <a:avLst/>
+          </a:prstGeom>
+          <a:noFill/>
+        </p:spPr>
+        <p:txBody>
+          <a:bodyPr wrap="square">
+            <a:spAutoFit/>
+          </a:bodyPr>
+          <a:lstStyle/>
+          <a:p>
+            <a:pPr>
+              <a:defRPr sz="1400" b="0">
+                <a:solidFill>
+                  <a:srgbClr val="EBF2FA"/>
+                </a:solidFill>
+              </a:defRPr>
+            </a:pPr>
+            <a:r>
+              <a:t>Synthetic • Spark local[1]/[2]</a:t>
+            </a:r>
+          </a:p>
+        </p:txBody>
+      </p:sp>
+      <p:sp>
+        <p:nvSpPr>
+          <p:cNvPr id="16" name="TextBox 15"/>
+          <p:cNvSpPr txBox="1"/>
+          <p:nvPr/>
+        </p:nvSpPr>
+        <p:spPr>
+          <a:xfrm>
+            <a:off x="4736592" y="2935224"/>
+            <a:ext cx="1325880" cy="384048"/>
+          </a:xfrm>
+          <a:prstGeom prst="rect">
+            <a:avLst/>
+          </a:prstGeom>
+          <a:noFill/>
+        </p:spPr>
+        <p:txBody>
+          <a:bodyPr wrap="square">
+            <a:spAutoFit/>
+          </a:bodyPr>
+          <a:lstStyle/>
+          <a:p>
+            <a:pPr>
+              <a:defRPr sz="1400" b="0">
+                <a:solidFill>
+                  <a:srgbClr val="EBF2FA"/>
+                </a:solidFill>
+              </a:defRPr>
+            </a:pPr>
+            <a:r>
+              <a:t>1,032.370</a:t>
+            </a:r>
+          </a:p>
+        </p:txBody>
+      </p:sp>
+      <p:sp>
+        <p:nvSpPr>
+          <p:cNvPr id="17" name="TextBox 16"/>
+          <p:cNvSpPr txBox="1"/>
+          <p:nvPr/>
+        </p:nvSpPr>
+        <p:spPr>
+          <a:xfrm>
+            <a:off x="6446520" y="2935224"/>
+            <a:ext cx="1005840" cy="384048"/>
+          </a:xfrm>
+          <a:prstGeom prst="rect">
+            <a:avLst/>
+          </a:prstGeom>
+          <a:noFill/>
+        </p:spPr>
+        <p:txBody>
+          <a:bodyPr wrap="square">
+            <a:spAutoFit/>
+          </a:bodyPr>
+          <a:lstStyle/>
+          <a:p>
+            <a:pPr>
+              <a:defRPr sz="1400" b="0">
+                <a:solidFill>
+                  <a:srgbClr val="EBF2FA"/>
+                </a:solidFill>
+              </a:defRPr>
+            </a:pPr>
+            <a:r>
+              <a:t>1.000</a:t>
+            </a:r>
+          </a:p>
+        </p:txBody>
+      </p:sp>
+      <p:sp>
+        <p:nvSpPr>
+          <p:cNvPr id="18" name="TextBox 17"/>
+          <p:cNvSpPr txBox="1"/>
+          <p:nvPr/>
+        </p:nvSpPr>
+        <p:spPr>
+          <a:xfrm>
+            <a:off x="7772400" y="2935224"/>
+            <a:ext cx="914400" cy="384048"/>
+          </a:xfrm>
+          <a:prstGeom prst="rect">
+            <a:avLst/>
+          </a:prstGeom>
+          <a:noFill/>
+        </p:spPr>
+        <p:txBody>
+          <a:bodyPr wrap="square">
+            <a:spAutoFit/>
+          </a:bodyPr>
+          <a:lstStyle/>
+          <a:p>
+            <a:pPr>
+              <a:defRPr sz="1400" b="0">
+                <a:solidFill>
+                  <a:srgbClr val="EBF2FA"/>
+                </a:solidFill>
+              </a:defRPr>
+            </a:pPr>
+            <a:r>
+              <a:t>1.000</a:t>
+            </a:r>
+          </a:p>
+        </p:txBody>
+      </p:sp>
+      <p:sp>
+        <p:nvSpPr>
+          <p:cNvPr id="19" name="TextBox 18"/>
+          <p:cNvSpPr txBox="1"/>
+          <p:nvPr/>
+        </p:nvSpPr>
+        <p:spPr>
+          <a:xfrm>
+            <a:off x="8997696" y="2935224"/>
+            <a:ext cx="914400" cy="384048"/>
+          </a:xfrm>
+          <a:prstGeom prst="rect">
+            <a:avLst/>
+          </a:prstGeom>
+          <a:noFill/>
+        </p:spPr>
+        <p:txBody>
+          <a:bodyPr wrap="square">
+            <a:spAutoFit/>
+          </a:bodyPr>
+          <a:lstStyle/>
+          <a:p>
+            <a:pPr>
+              <a:defRPr sz="1400" b="0">
+                <a:solidFill>
+                  <a:srgbClr val="EBF2FA"/>
+                </a:solidFill>
+              </a:defRPr>
+            </a:pPr>
+            <a:r>
+              <a:t>1.000</a:t>
+            </a:r>
+          </a:p>
+        </p:txBody>
+      </p:sp>
+      <p:sp>
+        <p:nvSpPr>
+          <p:cNvPr id="20" name="TextBox 19"/>
+          <p:cNvSpPr txBox="1"/>
+          <p:nvPr/>
+        </p:nvSpPr>
+        <p:spPr>
+          <a:xfrm>
+            <a:off x="594360" y="3374136"/>
+            <a:ext cx="3977639" cy="384048"/>
+          </a:xfrm>
+          <a:prstGeom prst="rect">
+            <a:avLst/>
+          </a:prstGeom>
+          <a:noFill/>
+        </p:spPr>
+        <p:txBody>
+          <a:bodyPr wrap="square">
+            <a:spAutoFit/>
+          </a:bodyPr>
+          <a:lstStyle/>
+          <a:p>
+            <a:pPr>
+              <a:defRPr sz="1400" b="0">
+                <a:solidFill>
+                  <a:srgbClr val="EBF2FA"/>
+                </a:solidFill>
+              </a:defRPr>
+            </a:pPr>
+            <a:r>
+              <a:t>KDD99 • Traditional</a:t>
+            </a:r>
+          </a:p>
+        </p:txBody>
+      </p:sp>
+      <p:sp>
+        <p:nvSpPr>
+          <p:cNvPr id="21" name="TextBox 20"/>
+          <p:cNvSpPr txBox="1"/>
+          <p:nvPr/>
+        </p:nvSpPr>
+        <p:spPr>
+          <a:xfrm>
+            <a:off x="4736592" y="3374136"/>
+            <a:ext cx="1325880" cy="384048"/>
+          </a:xfrm>
+          <a:prstGeom prst="rect">
+            <a:avLst/>
+          </a:prstGeom>
+          <a:noFill/>
+        </p:spPr>
+        <p:txBody>
+          <a:bodyPr wrap="square">
+            <a:spAutoFit/>
+          </a:bodyPr>
+          <a:lstStyle/>
+          <a:p>
+            <a:pPr>
+              <a:defRPr sz="1400" b="0">
+                <a:solidFill>
+                  <a:srgbClr val="EBF2FA"/>
+                </a:solidFill>
+              </a:defRPr>
+            </a:pPr>
+            <a:r>
+              <a:t>9,342.830</a:t>
+            </a:r>
+          </a:p>
+        </p:txBody>
+      </p:sp>
+      <p:sp>
+        <p:nvSpPr>
+          <p:cNvPr id="22" name="TextBox 21"/>
+          <p:cNvSpPr txBox="1"/>
+          <p:nvPr/>
+        </p:nvSpPr>
+        <p:spPr>
+          <a:xfrm>
+            <a:off x="6446520" y="3374136"/>
+            <a:ext cx="1005840" cy="384048"/>
+          </a:xfrm>
+          <a:prstGeom prst="rect">
+            <a:avLst/>
+          </a:prstGeom>
+          <a:noFill/>
+        </p:spPr>
+        <p:txBody>
+          <a:bodyPr wrap="square">
+            <a:spAutoFit/>
+          </a:bodyPr>
+          <a:lstStyle/>
+          <a:p>
+            <a:pPr>
+              <a:defRPr sz="1400" b="0">
+                <a:solidFill>
+                  <a:srgbClr val="EBF2FA"/>
+                </a:solidFill>
+              </a:defRPr>
+            </a:pPr>
+            <a:r>
+              <a:t>0.975</a:t>
+            </a:r>
+          </a:p>
+        </p:txBody>
+      </p:sp>
+      <p:sp>
+        <p:nvSpPr>
+          <p:cNvPr id="23" name="TextBox 22"/>
+          <p:cNvSpPr txBox="1"/>
+          <p:nvPr/>
+        </p:nvSpPr>
+        <p:spPr>
+          <a:xfrm>
+            <a:off x="7772400" y="3374136"/>
+            <a:ext cx="914400" cy="384048"/>
+          </a:xfrm>
+          <a:prstGeom prst="rect">
+            <a:avLst/>
+          </a:prstGeom>
+          <a:noFill/>
+        </p:spPr>
+        <p:txBody>
+          <a:bodyPr wrap="square">
+            <a:spAutoFit/>
+          </a:bodyPr>
+          <a:lstStyle/>
+          <a:p>
+            <a:pPr>
+              <a:defRPr sz="1400" b="0">
+                <a:solidFill>
+                  <a:srgbClr val="EBF2FA"/>
+                </a:solidFill>
+              </a:defRPr>
+            </a:pPr>
+            <a:r>
+              <a:t>0.432</a:t>
+            </a:r>
+          </a:p>
+        </p:txBody>
+      </p:sp>
+      <p:sp>
+        <p:nvSpPr>
+          <p:cNvPr id="24" name="TextBox 23"/>
+          <p:cNvSpPr txBox="1"/>
+          <p:nvPr/>
+        </p:nvSpPr>
+        <p:spPr>
+          <a:xfrm>
+            <a:off x="8997696" y="3374136"/>
+            <a:ext cx="914400" cy="384048"/>
+          </a:xfrm>
+          <a:prstGeom prst="rect">
+            <a:avLst/>
+          </a:prstGeom>
+          <a:noFill/>
+        </p:spPr>
+        <p:txBody>
+          <a:bodyPr wrap="square">
+            <a:spAutoFit/>
+          </a:bodyPr>
+          <a:lstStyle/>
+          <a:p>
+            <a:pPr>
+              <a:defRPr sz="1400" b="0">
+                <a:solidFill>
+                  <a:srgbClr val="EBF2FA"/>
+                </a:solidFill>
+              </a:defRPr>
+            </a:pPr>
+            <a:r>
+              <a:t>0.535</a:t>
+            </a:r>
+          </a:p>
+        </p:txBody>
+      </p:sp>
+      <p:sp>
+        <p:nvSpPr>
+          <p:cNvPr id="25" name="TextBox 24"/>
+          <p:cNvSpPr txBox="1"/>
+          <p:nvPr/>
+        </p:nvSpPr>
+        <p:spPr>
+          <a:xfrm>
+            <a:off x="594360" y="3813048"/>
+            <a:ext cx="3977639" cy="384048"/>
+          </a:xfrm>
+          <a:prstGeom prst="rect">
+            <a:avLst/>
+          </a:prstGeom>
+          <a:noFill/>
+        </p:spPr>
+        <p:txBody>
+          <a:bodyPr wrap="square">
+            <a:spAutoFit/>
+          </a:bodyPr>
+          <a:lstStyle/>
+          <a:p>
+            <a:pPr>
+              <a:defRPr sz="1400" b="0">
+                <a:solidFill>
+                  <a:srgbClr val="EBF2FA"/>
+                </a:solidFill>
+              </a:defRPr>
+            </a:pPr>
+            <a:r>
+              <a:t>KDD99 • Spark local[1]/[2]</a:t>
+            </a:r>
+          </a:p>
+        </p:txBody>
+      </p:sp>
+      <p:sp>
+        <p:nvSpPr>
+          <p:cNvPr id="26" name="TextBox 25"/>
+          <p:cNvSpPr txBox="1"/>
+          <p:nvPr/>
+        </p:nvSpPr>
+        <p:spPr>
+          <a:xfrm>
+            <a:off x="4736592" y="3813048"/>
+            <a:ext cx="1325880" cy="384048"/>
+          </a:xfrm>
+          <a:prstGeom prst="rect">
+            <a:avLst/>
+          </a:prstGeom>
+          <a:noFill/>
+        </p:spPr>
+        <p:txBody>
+          <a:bodyPr wrap="square">
+            <a:spAutoFit/>
+          </a:bodyPr>
+          <a:lstStyle/>
+          <a:p>
+            <a:pPr>
+              <a:defRPr sz="1400" b="0">
+                <a:solidFill>
+                  <a:srgbClr val="EBF2FA"/>
+                </a:solidFill>
+              </a:defRPr>
+            </a:pPr>
+            <a:r>
+              <a:t>21,072.555</a:t>
+            </a:r>
+          </a:p>
+        </p:txBody>
+      </p:sp>
+      <p:sp>
+        <p:nvSpPr>
+          <p:cNvPr id="27" name="TextBox 26"/>
+          <p:cNvSpPr txBox="1"/>
+          <p:nvPr/>
+        </p:nvSpPr>
+        <p:spPr>
+          <a:xfrm>
+            <a:off x="6446520" y="3813048"/>
+            <a:ext cx="1005840" cy="384048"/>
+          </a:xfrm>
+          <a:prstGeom prst="rect">
+            <a:avLst/>
+          </a:prstGeom>
+          <a:noFill/>
+        </p:spPr>
+        <p:txBody>
+          <a:bodyPr wrap="square">
+            <a:spAutoFit/>
+          </a:bodyPr>
+          <a:lstStyle/>
+          <a:p>
+            <a:pPr>
+              <a:defRPr sz="1400" b="0">
+                <a:solidFill>
+                  <a:srgbClr val="EBF2FA"/>
+                </a:solidFill>
+              </a:defRPr>
+            </a:pPr>
+            <a:r>
+              <a:t>0.797</a:t>
+            </a:r>
+          </a:p>
+        </p:txBody>
+      </p:sp>
+      <p:sp>
+        <p:nvSpPr>
+          <p:cNvPr id="28" name="TextBox 27"/>
+          <p:cNvSpPr txBox="1"/>
+          <p:nvPr/>
+        </p:nvSpPr>
+        <p:spPr>
+          <a:xfrm>
+            <a:off x="7772400" y="3813048"/>
+            <a:ext cx="914400" cy="384048"/>
+          </a:xfrm>
+          <a:prstGeom prst="rect">
+            <a:avLst/>
+          </a:prstGeom>
+          <a:noFill/>
+        </p:spPr>
+        <p:txBody>
+          <a:bodyPr wrap="square">
+            <a:spAutoFit/>
+          </a:bodyPr>
+          <a:lstStyle/>
+          <a:p>
+            <a:pPr>
+              <a:defRPr sz="1400" b="0">
+                <a:solidFill>
+                  <a:srgbClr val="EBF2FA"/>
+                </a:solidFill>
+              </a:defRPr>
+            </a:pPr>
+            <a:r>
+              <a:t>-0.005</a:t>
+            </a:r>
+          </a:p>
+        </p:txBody>
+      </p:sp>
+      <p:sp>
+        <p:nvSpPr>
+          <p:cNvPr id="29" name="TextBox 28"/>
+          <p:cNvSpPr txBox="1"/>
+          <p:nvPr/>
+        </p:nvSpPr>
+        <p:spPr>
+          <a:xfrm>
+            <a:off x="8997696" y="3813048"/>
+            <a:ext cx="914400" cy="384048"/>
+          </a:xfrm>
+          <a:prstGeom prst="rect">
+            <a:avLst/>
+          </a:prstGeom>
+          <a:noFill/>
+        </p:spPr>
+        <p:txBody>
+          <a:bodyPr wrap="square">
+            <a:spAutoFit/>
+          </a:bodyPr>
+          <a:lstStyle/>
+          <a:p>
+            <a:pPr>
+              <a:defRPr sz="1400" b="0">
+                <a:solidFill>
+                  <a:srgbClr val="EBF2FA"/>
+                </a:solidFill>
+              </a:defRPr>
+            </a:pPr>
+            <a:r>
+              <a:t>0.011</a:t>
+            </a:r>
+          </a:p>
+        </p:txBody>
+      </p:sp>
+      <p:sp>
+        <p:nvSpPr>
+          <p:cNvPr id="30" name="TextBox 29"/>
+          <p:cNvSpPr txBox="1"/>
+          <p:nvPr/>
+        </p:nvSpPr>
+        <p:spPr>
+          <a:xfrm>
+            <a:off x="594360" y="4498848"/>
+            <a:ext cx="11094720" cy="411480"/>
+          </a:xfrm>
+          <a:prstGeom prst="rect">
+            <a:avLst/>
+          </a:prstGeom>
+          <a:noFill/>
+        </p:spPr>
+        <p:txBody>
+          <a:bodyPr wrap="square">
+            <a:spAutoFit/>
+          </a:bodyPr>
+          <a:lstStyle/>
+          <a:p>
+            <a:pPr>
+              <a:defRPr sz="1500" b="1">
+                <a:solidFill>
+                  <a:srgbClr val="5BCCE6"/>
+                </a:solidFill>
+              </a:defRPr>
+            </a:pPr>
+            <a:r>
+              <a:t>All four Spark runs passed independent SSE, assignment, and cluster-count checks.</a:t>
+            </a:r>
+          </a:p>
+        </p:txBody>
+      </p:sp>
+      <p:sp>
+        <p:nvSpPr>
+          <p:cNvPr id="31" name="TextBox 30"/>
+          <p:cNvSpPr txBox="1"/>
+          <p:nvPr/>
+        </p:nvSpPr>
+        <p:spPr>
+          <a:xfrm>
+            <a:off x="594360" y="5010912"/>
+            <a:ext cx="11094720" cy="960120"/>
+          </a:xfrm>
+          <a:prstGeom prst="rect">
+            <a:avLst/>
+          </a:prstGeom>
+          <a:noFill/>
+        </p:spPr>
+        <p:txBody>
+          <a:bodyPr wrap="square">
+            <a:spAutoFit/>
+          </a:bodyPr>
+          <a:lstStyle/>
+          <a:p>
+            <a:pPr>
+              <a:defRPr sz="1400" b="0">
+                <a:solidFill>
+                  <a:srgbClr val="EBF2FA"/>
+                </a:solidFill>
+              </a:defRPr>
+            </a:pPr>
+            <a:r>
+              <a:t>KDD99 purity 0.797 is near the 0.795 majority-class reference. This five-cluster check is separate from the earlier four-cluster, 42-run controlled study. Spark local[n] uses one computer.</a:t>
+            </a:r>
+          </a:p>
+        </p:txBody>
+      </p:sp>
+      <p:sp>
+        <p:nvSpPr>
+          <p:cNvPr id="19" name="TextBox 18"/>
+          <p:cNvSpPr txBox="1"/>
+          <p:nvPr/>
+        </p:nvSpPr>
+        <p:spPr>
+          <a:xfrm>
+            <a:off x="612648" y="6446520"/>
+            <a:ext cx="10820095" cy="237744"/>
+          </a:xfrm>
+          <a:prstGeom prst="rect">
+            <a:avLst/>
+          </a:prstGeom>
+          <a:noFill/>
+        </p:spPr>
+        <p:txBody>
+          <a:bodyPr wrap="square" lIns="36576" rIns="36576">
+            <a:spAutoFit/>
+          </a:bodyPr>
+          <a:lstStyle/>
+          <a:p>
+            <a:pPr>
+              <a:defRPr sz="900" b="0">
+                <a:solidFill>
+                  <a:srgbClr val="566874"/>
+                </a:solidFill>
+                <a:latin typeface="Aptos"/>
+              </a:defRPr>
+            </a:pPr>
+            <a:r>
+              <a:t>CSCE 5300  /  GROUP 7</a:t>
+            </a:r>
+          </a:p>
+        </p:txBody>
+      </p:sp>
+      <p:sp>
+        <p:nvSpPr>
+          <p:cNvPr id="20" name="TextBox 19"/>
+          <p:cNvSpPr txBox="1"/>
+          <p:nvPr/>
+        </p:nvSpPr>
+        <p:spPr>
+          <a:xfrm>
+            <a:off x="11167567" y="6446520"/>
+            <a:ext cx="658368" cy="237744"/>
+          </a:xfrm>
+          <a:prstGeom prst="rect">
+            <a:avLst/>
+          </a:prstGeom>
+          <a:noFill/>
+        </p:spPr>
+        <p:txBody>
+          <a:bodyPr wrap="square" lIns="36576" rIns="36576">
+            <a:spAutoFit/>
+          </a:bodyPr>
+          <a:lstStyle/>
+          <a:p>
+            <a:pPr algn="r">
+              <a:defRPr sz="900" b="0">
+                <a:solidFill>
+                  <a:srgbClr val="566874"/>
+                </a:solidFill>
+                <a:latin typeface="Aptos"/>
+              </a:defRPr>
+            </a:pPr>
+            <a:r>
+              <a:t>23 / 24</a:t>
+            </a:r>
+          </a:p>
+        </p:txBody>
+      </p:sp>
+    </p:spTree>
+  </p:cSld>
+  <p:clrMapOvr>
+    <a:masterClrMapping/>
+  </p:clrMapOvr>
+</p:sld>
+</file>
+
+<file path=ppt/slides/slide24.xml><?xml version="1.0" encoding="utf-8"?>
 <p:sld xmlns:a="http://schemas.openxmlformats.org/drawingml/2006/main" xmlns:r="http://schemas.openxmlformats.org/officeDocument/2006/relationships" xmlns:p="http://schemas.openxmlformats.org/presentationml/2006/main">
   <p:cSld>
     <p:bg>
@@ -15421,7 +16569,7 @@
           <a:lstStyle/>
           <a:p>
             <a:r>
-              <a:t>23 / 23</a:t>
+              <a:t>24 / 24</a:t>
             </a:r>
           </a:p>
         </p:txBody>
@@ -15696,1082 +16844,6 @@
             </a:pPr>
             <a:r>
               <a:t>[5] Apache Software Foundation, “RDD Programming Guide,” Spark Documentation.</a:t>
-            </a:r>
-          </a:p>
-        </p:txBody>
-      </p:sp>
-    </p:spTree>
-  </p:cSld>
-  <p:clrMapOvr>
-    <a:masterClrMapping/>
-  </p:clrMapOvr>
-</p:sld>
-</file>
-
-<file path=ppt/slides/slide24.xml><?xml version="1.0" encoding="utf-8"?>
-<p:sld xmlns:a="http://schemas.openxmlformats.org/drawingml/2006/main" xmlns:p="http://schemas.openxmlformats.org/presentationml/2006/main" xmlns:r="http://schemas.openxmlformats.org/officeDocument/2006/relationships">
-  <p:cSld>
-    <p:bg>
-      <p:bgPr>
-        <a:solidFill>
-          <a:srgbClr val="0D192D"/>
-        </a:solidFill>
-        <a:effectLst/>
-      </p:bgPr>
-    </p:bg>
-    <p:spTree>
-      <p:nvGrpSpPr>
-        <p:cNvPr id="1" name=""/>
-        <p:cNvGrpSpPr/>
-        <p:nvPr/>
-      </p:nvGrpSpPr>
-      <p:grpSpPr/>
-      <p:sp>
-        <p:nvSpPr>
-          <p:cNvPr id="2" name="TextBox 1"/>
-          <p:cNvSpPr txBox="1"/>
-          <p:nvPr/>
-        </p:nvSpPr>
-        <p:spPr>
-          <a:xfrm>
-            <a:off x="594360" y="347472"/>
-            <a:ext cx="11003280" cy="329184"/>
-          </a:xfrm>
-          <a:prstGeom prst="rect">
-            <a:avLst/>
-          </a:prstGeom>
-          <a:noFill/>
-        </p:spPr>
-        <p:txBody>
-          <a:bodyPr wrap="square">
-            <a:spAutoFit/>
-          </a:bodyPr>
-          <a:lstStyle/>
-          <a:p>
-            <a:pPr>
-              <a:defRPr sz="1400" b="1">
-                <a:solidFill>
-                  <a:srgbClr val="5BCCE6"/>
-                </a:solidFill>
-              </a:defRPr>
-            </a:pPr>
-            <a:r>
-              <a:t>SUPPLEMENTARY VERIFICATION</a:t>
-            </a:r>
-          </a:p>
-        </p:txBody>
-      </p:sp>
-      <p:sp>
-        <p:nvSpPr>
-          <p:cNvPr id="3" name="TextBox 2"/>
-          <p:cNvSpPr txBox="1"/>
-          <p:nvPr/>
-        </p:nvSpPr>
-        <p:spPr>
-          <a:xfrm>
-            <a:off x="594360" y="822960"/>
-            <a:ext cx="11094720" cy="640080"/>
-          </a:xfrm>
-          <a:prstGeom prst="rect">
-            <a:avLst/>
-          </a:prstGeom>
-          <a:noFill/>
-        </p:spPr>
-        <p:txBody>
-          <a:bodyPr wrap="square">
-            <a:spAutoFit/>
-          </a:bodyPr>
-          <a:lstStyle/>
-          <a:p>
-            <a:pPr>
-              <a:defRPr sz="2700" b="1">
-                <a:solidFill>
-                  <a:srgbClr val="EBF2FA"/>
-                </a:solidFill>
-              </a:defRPr>
-            </a:pPr>
-            <a:r>
-              <a:t>Independent SSE &amp; cluster-quality checks</a:t>
-            </a:r>
-          </a:p>
-        </p:txBody>
-      </p:sp>
-      <p:sp>
-        <p:nvSpPr>
-          <p:cNvPr id="4" name="TextBox 3"/>
-          <p:cNvSpPr txBox="1"/>
-          <p:nvPr/>
-        </p:nvSpPr>
-        <p:spPr>
-          <a:xfrm>
-            <a:off x="594360" y="1527048"/>
-            <a:ext cx="11094720" cy="365760"/>
-          </a:xfrm>
-          <a:prstGeom prst="rect">
-            <a:avLst/>
-          </a:prstGeom>
-          <a:noFill/>
-        </p:spPr>
-        <p:txBody>
-          <a:bodyPr wrap="square">
-            <a:spAutoFit/>
-          </a:bodyPr>
-          <a:lstStyle/>
-          <a:p>
-            <a:pPr>
-              <a:defRPr sz="1600" b="0">
-                <a:solidFill>
-                  <a:srgbClr val="EBF2FA"/>
-                </a:solidFill>
-              </a:defRPr>
-            </a:pPr>
-            <a:r>
-              <a:t>1,000 records  •  2 partitions  •  seed 42  •  5 clusters</a:t>
-            </a:r>
-          </a:p>
-        </p:txBody>
-      </p:sp>
-      <p:sp>
-        <p:nvSpPr>
-          <p:cNvPr id="5" name="TextBox 4"/>
-          <p:cNvSpPr txBox="1"/>
-          <p:nvPr/>
-        </p:nvSpPr>
-        <p:spPr>
-          <a:xfrm>
-            <a:off x="594360" y="2057400"/>
-            <a:ext cx="3977639" cy="329184"/>
-          </a:xfrm>
-          <a:prstGeom prst="rect">
-            <a:avLst/>
-          </a:prstGeom>
-          <a:noFill/>
-        </p:spPr>
-        <p:txBody>
-          <a:bodyPr wrap="square">
-            <a:spAutoFit/>
-          </a:bodyPr>
-          <a:lstStyle/>
-          <a:p>
-            <a:pPr>
-              <a:defRPr sz="1500" b="1">
-                <a:solidFill>
-                  <a:srgbClr val="5BCCE6"/>
-                </a:solidFill>
-              </a:defRPr>
-            </a:pPr>
-            <a:r>
-              <a:t>Dataset / method</a:t>
-            </a:r>
-          </a:p>
-        </p:txBody>
-      </p:sp>
-      <p:sp>
-        <p:nvSpPr>
-          <p:cNvPr id="6" name="TextBox 5"/>
-          <p:cNvSpPr txBox="1"/>
-          <p:nvPr/>
-        </p:nvSpPr>
-        <p:spPr>
-          <a:xfrm>
-            <a:off x="4736592" y="2057400"/>
-            <a:ext cx="1325880" cy="329184"/>
-          </a:xfrm>
-          <a:prstGeom prst="rect">
-            <a:avLst/>
-          </a:prstGeom>
-          <a:noFill/>
-        </p:spPr>
-        <p:txBody>
-          <a:bodyPr wrap="square">
-            <a:spAutoFit/>
-          </a:bodyPr>
-          <a:lstStyle/>
-          <a:p>
-            <a:pPr>
-              <a:defRPr sz="1500" b="1">
-                <a:solidFill>
-                  <a:srgbClr val="5BCCE6"/>
-                </a:solidFill>
-              </a:defRPr>
-            </a:pPr>
-            <a:r>
-              <a:t>SSE</a:t>
-            </a:r>
-          </a:p>
-        </p:txBody>
-      </p:sp>
-      <p:sp>
-        <p:nvSpPr>
-          <p:cNvPr id="7" name="TextBox 6"/>
-          <p:cNvSpPr txBox="1"/>
-          <p:nvPr/>
-        </p:nvSpPr>
-        <p:spPr>
-          <a:xfrm>
-            <a:off x="6446520" y="2057400"/>
-            <a:ext cx="1005840" cy="329184"/>
-          </a:xfrm>
-          <a:prstGeom prst="rect">
-            <a:avLst/>
-          </a:prstGeom>
-          <a:noFill/>
-        </p:spPr>
-        <p:txBody>
-          <a:bodyPr wrap="square">
-            <a:spAutoFit/>
-          </a:bodyPr>
-          <a:lstStyle/>
-          <a:p>
-            <a:pPr>
-              <a:defRPr sz="1500" b="1">
-                <a:solidFill>
-                  <a:srgbClr val="5BCCE6"/>
-                </a:solidFill>
-              </a:defRPr>
-            </a:pPr>
-            <a:r>
-              <a:t>Purity</a:t>
-            </a:r>
-          </a:p>
-        </p:txBody>
-      </p:sp>
-      <p:sp>
-        <p:nvSpPr>
-          <p:cNvPr id="8" name="TextBox 7"/>
-          <p:cNvSpPr txBox="1"/>
-          <p:nvPr/>
-        </p:nvSpPr>
-        <p:spPr>
-          <a:xfrm>
-            <a:off x="7772400" y="2057400"/>
-            <a:ext cx="914400" cy="329184"/>
-          </a:xfrm>
-          <a:prstGeom prst="rect">
-            <a:avLst/>
-          </a:prstGeom>
-          <a:noFill/>
-        </p:spPr>
-        <p:txBody>
-          <a:bodyPr wrap="square">
-            <a:spAutoFit/>
-          </a:bodyPr>
-          <a:lstStyle/>
-          <a:p>
-            <a:pPr>
-              <a:defRPr sz="1500" b="1">
-                <a:solidFill>
-                  <a:srgbClr val="5BCCE6"/>
-                </a:solidFill>
-              </a:defRPr>
-            </a:pPr>
-            <a:r>
-              <a:t>ARI</a:t>
-            </a:r>
-          </a:p>
-        </p:txBody>
-      </p:sp>
-      <p:sp>
-        <p:nvSpPr>
-          <p:cNvPr id="9" name="TextBox 8"/>
-          <p:cNvSpPr txBox="1"/>
-          <p:nvPr/>
-        </p:nvSpPr>
-        <p:spPr>
-          <a:xfrm>
-            <a:off x="8997696" y="2057400"/>
-            <a:ext cx="914400" cy="329184"/>
-          </a:xfrm>
-          <a:prstGeom prst="rect">
-            <a:avLst/>
-          </a:prstGeom>
-          <a:noFill/>
-        </p:spPr>
-        <p:txBody>
-          <a:bodyPr wrap="square">
-            <a:spAutoFit/>
-          </a:bodyPr>
-          <a:lstStyle/>
-          <a:p>
-            <a:pPr>
-              <a:defRPr sz="1500" b="1">
-                <a:solidFill>
-                  <a:srgbClr val="5BCCE6"/>
-                </a:solidFill>
-              </a:defRPr>
-            </a:pPr>
-            <a:r>
-              <a:t>NMI</a:t>
-            </a:r>
-          </a:p>
-        </p:txBody>
-      </p:sp>
-      <p:sp>
-        <p:nvSpPr>
-          <p:cNvPr id="10" name="TextBox 9"/>
-          <p:cNvSpPr txBox="1"/>
-          <p:nvPr/>
-        </p:nvSpPr>
-        <p:spPr>
-          <a:xfrm>
-            <a:off x="594360" y="2496312"/>
-            <a:ext cx="3977639" cy="384048"/>
-          </a:xfrm>
-          <a:prstGeom prst="rect">
-            <a:avLst/>
-          </a:prstGeom>
-          <a:noFill/>
-        </p:spPr>
-        <p:txBody>
-          <a:bodyPr wrap="square">
-            <a:spAutoFit/>
-          </a:bodyPr>
-          <a:lstStyle/>
-          <a:p>
-            <a:pPr>
-              <a:defRPr sz="1400" b="0">
-                <a:solidFill>
-                  <a:srgbClr val="EBF2FA"/>
-                </a:solidFill>
-              </a:defRPr>
-            </a:pPr>
-            <a:r>
-              <a:t>Synthetic • Traditional</a:t>
-            </a:r>
-          </a:p>
-        </p:txBody>
-      </p:sp>
-      <p:sp>
-        <p:nvSpPr>
-          <p:cNvPr id="11" name="TextBox 10"/>
-          <p:cNvSpPr txBox="1"/>
-          <p:nvPr/>
-        </p:nvSpPr>
-        <p:spPr>
-          <a:xfrm>
-            <a:off x="4736592" y="2496312"/>
-            <a:ext cx="1325880" cy="384048"/>
-          </a:xfrm>
-          <a:prstGeom prst="rect">
-            <a:avLst/>
-          </a:prstGeom>
-          <a:noFill/>
-        </p:spPr>
-        <p:txBody>
-          <a:bodyPr wrap="square">
-            <a:spAutoFit/>
-          </a:bodyPr>
-          <a:lstStyle/>
-          <a:p>
-            <a:pPr>
-              <a:defRPr sz="1400" b="0">
-                <a:solidFill>
-                  <a:srgbClr val="EBF2FA"/>
-                </a:solidFill>
-              </a:defRPr>
-            </a:pPr>
-            <a:r>
-              <a:t>1,032.370</a:t>
-            </a:r>
-          </a:p>
-        </p:txBody>
-      </p:sp>
-      <p:sp>
-        <p:nvSpPr>
-          <p:cNvPr id="12" name="TextBox 11"/>
-          <p:cNvSpPr txBox="1"/>
-          <p:nvPr/>
-        </p:nvSpPr>
-        <p:spPr>
-          <a:xfrm>
-            <a:off x="6446520" y="2496312"/>
-            <a:ext cx="1005840" cy="384048"/>
-          </a:xfrm>
-          <a:prstGeom prst="rect">
-            <a:avLst/>
-          </a:prstGeom>
-          <a:noFill/>
-        </p:spPr>
-        <p:txBody>
-          <a:bodyPr wrap="square">
-            <a:spAutoFit/>
-          </a:bodyPr>
-          <a:lstStyle/>
-          <a:p>
-            <a:pPr>
-              <a:defRPr sz="1400" b="0">
-                <a:solidFill>
-                  <a:srgbClr val="EBF2FA"/>
-                </a:solidFill>
-              </a:defRPr>
-            </a:pPr>
-            <a:r>
-              <a:t>1.000</a:t>
-            </a:r>
-          </a:p>
-        </p:txBody>
-      </p:sp>
-      <p:sp>
-        <p:nvSpPr>
-          <p:cNvPr id="13" name="TextBox 12"/>
-          <p:cNvSpPr txBox="1"/>
-          <p:nvPr/>
-        </p:nvSpPr>
-        <p:spPr>
-          <a:xfrm>
-            <a:off x="7772400" y="2496312"/>
-            <a:ext cx="914400" cy="384048"/>
-          </a:xfrm>
-          <a:prstGeom prst="rect">
-            <a:avLst/>
-          </a:prstGeom>
-          <a:noFill/>
-        </p:spPr>
-        <p:txBody>
-          <a:bodyPr wrap="square">
-            <a:spAutoFit/>
-          </a:bodyPr>
-          <a:lstStyle/>
-          <a:p>
-            <a:pPr>
-              <a:defRPr sz="1400" b="0">
-                <a:solidFill>
-                  <a:srgbClr val="EBF2FA"/>
-                </a:solidFill>
-              </a:defRPr>
-            </a:pPr>
-            <a:r>
-              <a:t>1.000</a:t>
-            </a:r>
-          </a:p>
-        </p:txBody>
-      </p:sp>
-      <p:sp>
-        <p:nvSpPr>
-          <p:cNvPr id="14" name="TextBox 13"/>
-          <p:cNvSpPr txBox="1"/>
-          <p:nvPr/>
-        </p:nvSpPr>
-        <p:spPr>
-          <a:xfrm>
-            <a:off x="8997696" y="2496312"/>
-            <a:ext cx="914400" cy="384048"/>
-          </a:xfrm>
-          <a:prstGeom prst="rect">
-            <a:avLst/>
-          </a:prstGeom>
-          <a:noFill/>
-        </p:spPr>
-        <p:txBody>
-          <a:bodyPr wrap="square">
-            <a:spAutoFit/>
-          </a:bodyPr>
-          <a:lstStyle/>
-          <a:p>
-            <a:pPr>
-              <a:defRPr sz="1400" b="0">
-                <a:solidFill>
-                  <a:srgbClr val="EBF2FA"/>
-                </a:solidFill>
-              </a:defRPr>
-            </a:pPr>
-            <a:r>
-              <a:t>1.000</a:t>
-            </a:r>
-          </a:p>
-        </p:txBody>
-      </p:sp>
-      <p:sp>
-        <p:nvSpPr>
-          <p:cNvPr id="15" name="TextBox 14"/>
-          <p:cNvSpPr txBox="1"/>
-          <p:nvPr/>
-        </p:nvSpPr>
-        <p:spPr>
-          <a:xfrm>
-            <a:off x="594360" y="2935224"/>
-            <a:ext cx="3977639" cy="384048"/>
-          </a:xfrm>
-          <a:prstGeom prst="rect">
-            <a:avLst/>
-          </a:prstGeom>
-          <a:noFill/>
-        </p:spPr>
-        <p:txBody>
-          <a:bodyPr wrap="square">
-            <a:spAutoFit/>
-          </a:bodyPr>
-          <a:lstStyle/>
-          <a:p>
-            <a:pPr>
-              <a:defRPr sz="1400" b="0">
-                <a:solidFill>
-                  <a:srgbClr val="EBF2FA"/>
-                </a:solidFill>
-              </a:defRPr>
-            </a:pPr>
-            <a:r>
-              <a:t>Synthetic • Spark local[1]/[2]</a:t>
-            </a:r>
-          </a:p>
-        </p:txBody>
-      </p:sp>
-      <p:sp>
-        <p:nvSpPr>
-          <p:cNvPr id="16" name="TextBox 15"/>
-          <p:cNvSpPr txBox="1"/>
-          <p:nvPr/>
-        </p:nvSpPr>
-        <p:spPr>
-          <a:xfrm>
-            <a:off x="4736592" y="2935224"/>
-            <a:ext cx="1325880" cy="384048"/>
-          </a:xfrm>
-          <a:prstGeom prst="rect">
-            <a:avLst/>
-          </a:prstGeom>
-          <a:noFill/>
-        </p:spPr>
-        <p:txBody>
-          <a:bodyPr wrap="square">
-            <a:spAutoFit/>
-          </a:bodyPr>
-          <a:lstStyle/>
-          <a:p>
-            <a:pPr>
-              <a:defRPr sz="1400" b="0">
-                <a:solidFill>
-                  <a:srgbClr val="EBF2FA"/>
-                </a:solidFill>
-              </a:defRPr>
-            </a:pPr>
-            <a:r>
-              <a:t>1,032.370</a:t>
-            </a:r>
-          </a:p>
-        </p:txBody>
-      </p:sp>
-      <p:sp>
-        <p:nvSpPr>
-          <p:cNvPr id="17" name="TextBox 16"/>
-          <p:cNvSpPr txBox="1"/>
-          <p:nvPr/>
-        </p:nvSpPr>
-        <p:spPr>
-          <a:xfrm>
-            <a:off x="6446520" y="2935224"/>
-            <a:ext cx="1005840" cy="384048"/>
-          </a:xfrm>
-          <a:prstGeom prst="rect">
-            <a:avLst/>
-          </a:prstGeom>
-          <a:noFill/>
-        </p:spPr>
-        <p:txBody>
-          <a:bodyPr wrap="square">
-            <a:spAutoFit/>
-          </a:bodyPr>
-          <a:lstStyle/>
-          <a:p>
-            <a:pPr>
-              <a:defRPr sz="1400" b="0">
-                <a:solidFill>
-                  <a:srgbClr val="EBF2FA"/>
-                </a:solidFill>
-              </a:defRPr>
-            </a:pPr>
-            <a:r>
-              <a:t>1.000</a:t>
-            </a:r>
-          </a:p>
-        </p:txBody>
-      </p:sp>
-      <p:sp>
-        <p:nvSpPr>
-          <p:cNvPr id="18" name="TextBox 17"/>
-          <p:cNvSpPr txBox="1"/>
-          <p:nvPr/>
-        </p:nvSpPr>
-        <p:spPr>
-          <a:xfrm>
-            <a:off x="7772400" y="2935224"/>
-            <a:ext cx="914400" cy="384048"/>
-          </a:xfrm>
-          <a:prstGeom prst="rect">
-            <a:avLst/>
-          </a:prstGeom>
-          <a:noFill/>
-        </p:spPr>
-        <p:txBody>
-          <a:bodyPr wrap="square">
-            <a:spAutoFit/>
-          </a:bodyPr>
-          <a:lstStyle/>
-          <a:p>
-            <a:pPr>
-              <a:defRPr sz="1400" b="0">
-                <a:solidFill>
-                  <a:srgbClr val="EBF2FA"/>
-                </a:solidFill>
-              </a:defRPr>
-            </a:pPr>
-            <a:r>
-              <a:t>1.000</a:t>
-            </a:r>
-          </a:p>
-        </p:txBody>
-      </p:sp>
-      <p:sp>
-        <p:nvSpPr>
-          <p:cNvPr id="19" name="TextBox 18"/>
-          <p:cNvSpPr txBox="1"/>
-          <p:nvPr/>
-        </p:nvSpPr>
-        <p:spPr>
-          <a:xfrm>
-            <a:off x="8997696" y="2935224"/>
-            <a:ext cx="914400" cy="384048"/>
-          </a:xfrm>
-          <a:prstGeom prst="rect">
-            <a:avLst/>
-          </a:prstGeom>
-          <a:noFill/>
-        </p:spPr>
-        <p:txBody>
-          <a:bodyPr wrap="square">
-            <a:spAutoFit/>
-          </a:bodyPr>
-          <a:lstStyle/>
-          <a:p>
-            <a:pPr>
-              <a:defRPr sz="1400" b="0">
-                <a:solidFill>
-                  <a:srgbClr val="EBF2FA"/>
-                </a:solidFill>
-              </a:defRPr>
-            </a:pPr>
-            <a:r>
-              <a:t>1.000</a:t>
-            </a:r>
-          </a:p>
-        </p:txBody>
-      </p:sp>
-      <p:sp>
-        <p:nvSpPr>
-          <p:cNvPr id="20" name="TextBox 19"/>
-          <p:cNvSpPr txBox="1"/>
-          <p:nvPr/>
-        </p:nvSpPr>
-        <p:spPr>
-          <a:xfrm>
-            <a:off x="594360" y="3374136"/>
-            <a:ext cx="3977639" cy="384048"/>
-          </a:xfrm>
-          <a:prstGeom prst="rect">
-            <a:avLst/>
-          </a:prstGeom>
-          <a:noFill/>
-        </p:spPr>
-        <p:txBody>
-          <a:bodyPr wrap="square">
-            <a:spAutoFit/>
-          </a:bodyPr>
-          <a:lstStyle/>
-          <a:p>
-            <a:pPr>
-              <a:defRPr sz="1400" b="0">
-                <a:solidFill>
-                  <a:srgbClr val="EBF2FA"/>
-                </a:solidFill>
-              </a:defRPr>
-            </a:pPr>
-            <a:r>
-              <a:t>KDD99 • Traditional</a:t>
-            </a:r>
-          </a:p>
-        </p:txBody>
-      </p:sp>
-      <p:sp>
-        <p:nvSpPr>
-          <p:cNvPr id="21" name="TextBox 20"/>
-          <p:cNvSpPr txBox="1"/>
-          <p:nvPr/>
-        </p:nvSpPr>
-        <p:spPr>
-          <a:xfrm>
-            <a:off x="4736592" y="3374136"/>
-            <a:ext cx="1325880" cy="384048"/>
-          </a:xfrm>
-          <a:prstGeom prst="rect">
-            <a:avLst/>
-          </a:prstGeom>
-          <a:noFill/>
-        </p:spPr>
-        <p:txBody>
-          <a:bodyPr wrap="square">
-            <a:spAutoFit/>
-          </a:bodyPr>
-          <a:lstStyle/>
-          <a:p>
-            <a:pPr>
-              <a:defRPr sz="1400" b="0">
-                <a:solidFill>
-                  <a:srgbClr val="EBF2FA"/>
-                </a:solidFill>
-              </a:defRPr>
-            </a:pPr>
-            <a:r>
-              <a:t>9,342.830</a:t>
-            </a:r>
-          </a:p>
-        </p:txBody>
-      </p:sp>
-      <p:sp>
-        <p:nvSpPr>
-          <p:cNvPr id="22" name="TextBox 21"/>
-          <p:cNvSpPr txBox="1"/>
-          <p:nvPr/>
-        </p:nvSpPr>
-        <p:spPr>
-          <a:xfrm>
-            <a:off x="6446520" y="3374136"/>
-            <a:ext cx="1005840" cy="384048"/>
-          </a:xfrm>
-          <a:prstGeom prst="rect">
-            <a:avLst/>
-          </a:prstGeom>
-          <a:noFill/>
-        </p:spPr>
-        <p:txBody>
-          <a:bodyPr wrap="square">
-            <a:spAutoFit/>
-          </a:bodyPr>
-          <a:lstStyle/>
-          <a:p>
-            <a:pPr>
-              <a:defRPr sz="1400" b="0">
-                <a:solidFill>
-                  <a:srgbClr val="EBF2FA"/>
-                </a:solidFill>
-              </a:defRPr>
-            </a:pPr>
-            <a:r>
-              <a:t>0.975</a:t>
-            </a:r>
-          </a:p>
-        </p:txBody>
-      </p:sp>
-      <p:sp>
-        <p:nvSpPr>
-          <p:cNvPr id="23" name="TextBox 22"/>
-          <p:cNvSpPr txBox="1"/>
-          <p:nvPr/>
-        </p:nvSpPr>
-        <p:spPr>
-          <a:xfrm>
-            <a:off x="7772400" y="3374136"/>
-            <a:ext cx="914400" cy="384048"/>
-          </a:xfrm>
-          <a:prstGeom prst="rect">
-            <a:avLst/>
-          </a:prstGeom>
-          <a:noFill/>
-        </p:spPr>
-        <p:txBody>
-          <a:bodyPr wrap="square">
-            <a:spAutoFit/>
-          </a:bodyPr>
-          <a:lstStyle/>
-          <a:p>
-            <a:pPr>
-              <a:defRPr sz="1400" b="0">
-                <a:solidFill>
-                  <a:srgbClr val="EBF2FA"/>
-                </a:solidFill>
-              </a:defRPr>
-            </a:pPr>
-            <a:r>
-              <a:t>0.432</a:t>
-            </a:r>
-          </a:p>
-        </p:txBody>
-      </p:sp>
-      <p:sp>
-        <p:nvSpPr>
-          <p:cNvPr id="24" name="TextBox 23"/>
-          <p:cNvSpPr txBox="1"/>
-          <p:nvPr/>
-        </p:nvSpPr>
-        <p:spPr>
-          <a:xfrm>
-            <a:off x="8997696" y="3374136"/>
-            <a:ext cx="914400" cy="384048"/>
-          </a:xfrm>
-          <a:prstGeom prst="rect">
-            <a:avLst/>
-          </a:prstGeom>
-          <a:noFill/>
-        </p:spPr>
-        <p:txBody>
-          <a:bodyPr wrap="square">
-            <a:spAutoFit/>
-          </a:bodyPr>
-          <a:lstStyle/>
-          <a:p>
-            <a:pPr>
-              <a:defRPr sz="1400" b="0">
-                <a:solidFill>
-                  <a:srgbClr val="EBF2FA"/>
-                </a:solidFill>
-              </a:defRPr>
-            </a:pPr>
-            <a:r>
-              <a:t>0.535</a:t>
-            </a:r>
-          </a:p>
-        </p:txBody>
-      </p:sp>
-      <p:sp>
-        <p:nvSpPr>
-          <p:cNvPr id="25" name="TextBox 24"/>
-          <p:cNvSpPr txBox="1"/>
-          <p:nvPr/>
-        </p:nvSpPr>
-        <p:spPr>
-          <a:xfrm>
-            <a:off x="594360" y="3813048"/>
-            <a:ext cx="3977639" cy="384048"/>
-          </a:xfrm>
-          <a:prstGeom prst="rect">
-            <a:avLst/>
-          </a:prstGeom>
-          <a:noFill/>
-        </p:spPr>
-        <p:txBody>
-          <a:bodyPr wrap="square">
-            <a:spAutoFit/>
-          </a:bodyPr>
-          <a:lstStyle/>
-          <a:p>
-            <a:pPr>
-              <a:defRPr sz="1400" b="0">
-                <a:solidFill>
-                  <a:srgbClr val="EBF2FA"/>
-                </a:solidFill>
-              </a:defRPr>
-            </a:pPr>
-            <a:r>
-              <a:t>KDD99 • Spark local[1]/[2]</a:t>
-            </a:r>
-          </a:p>
-        </p:txBody>
-      </p:sp>
-      <p:sp>
-        <p:nvSpPr>
-          <p:cNvPr id="26" name="TextBox 25"/>
-          <p:cNvSpPr txBox="1"/>
-          <p:nvPr/>
-        </p:nvSpPr>
-        <p:spPr>
-          <a:xfrm>
-            <a:off x="4736592" y="3813048"/>
-            <a:ext cx="1325880" cy="384048"/>
-          </a:xfrm>
-          <a:prstGeom prst="rect">
-            <a:avLst/>
-          </a:prstGeom>
-          <a:noFill/>
-        </p:spPr>
-        <p:txBody>
-          <a:bodyPr wrap="square">
-            <a:spAutoFit/>
-          </a:bodyPr>
-          <a:lstStyle/>
-          <a:p>
-            <a:pPr>
-              <a:defRPr sz="1400" b="0">
-                <a:solidFill>
-                  <a:srgbClr val="EBF2FA"/>
-                </a:solidFill>
-              </a:defRPr>
-            </a:pPr>
-            <a:r>
-              <a:t>21,072.555</a:t>
-            </a:r>
-          </a:p>
-        </p:txBody>
-      </p:sp>
-      <p:sp>
-        <p:nvSpPr>
-          <p:cNvPr id="27" name="TextBox 26"/>
-          <p:cNvSpPr txBox="1"/>
-          <p:nvPr/>
-        </p:nvSpPr>
-        <p:spPr>
-          <a:xfrm>
-            <a:off x="6446520" y="3813048"/>
-            <a:ext cx="1005840" cy="384048"/>
-          </a:xfrm>
-          <a:prstGeom prst="rect">
-            <a:avLst/>
-          </a:prstGeom>
-          <a:noFill/>
-        </p:spPr>
-        <p:txBody>
-          <a:bodyPr wrap="square">
-            <a:spAutoFit/>
-          </a:bodyPr>
-          <a:lstStyle/>
-          <a:p>
-            <a:pPr>
-              <a:defRPr sz="1400" b="0">
-                <a:solidFill>
-                  <a:srgbClr val="EBF2FA"/>
-                </a:solidFill>
-              </a:defRPr>
-            </a:pPr>
-            <a:r>
-              <a:t>0.797</a:t>
-            </a:r>
-          </a:p>
-        </p:txBody>
-      </p:sp>
-      <p:sp>
-        <p:nvSpPr>
-          <p:cNvPr id="28" name="TextBox 27"/>
-          <p:cNvSpPr txBox="1"/>
-          <p:nvPr/>
-        </p:nvSpPr>
-        <p:spPr>
-          <a:xfrm>
-            <a:off x="7772400" y="3813048"/>
-            <a:ext cx="914400" cy="384048"/>
-          </a:xfrm>
-          <a:prstGeom prst="rect">
-            <a:avLst/>
-          </a:prstGeom>
-          <a:noFill/>
-        </p:spPr>
-        <p:txBody>
-          <a:bodyPr wrap="square">
-            <a:spAutoFit/>
-          </a:bodyPr>
-          <a:lstStyle/>
-          <a:p>
-            <a:pPr>
-              <a:defRPr sz="1400" b="0">
-                <a:solidFill>
-                  <a:srgbClr val="EBF2FA"/>
-                </a:solidFill>
-              </a:defRPr>
-            </a:pPr>
-            <a:r>
-              <a:t>-0.005</a:t>
-            </a:r>
-          </a:p>
-        </p:txBody>
-      </p:sp>
-      <p:sp>
-        <p:nvSpPr>
-          <p:cNvPr id="29" name="TextBox 28"/>
-          <p:cNvSpPr txBox="1"/>
-          <p:nvPr/>
-        </p:nvSpPr>
-        <p:spPr>
-          <a:xfrm>
-            <a:off x="8997696" y="3813048"/>
-            <a:ext cx="914400" cy="384048"/>
-          </a:xfrm>
-          <a:prstGeom prst="rect">
-            <a:avLst/>
-          </a:prstGeom>
-          <a:noFill/>
-        </p:spPr>
-        <p:txBody>
-          <a:bodyPr wrap="square">
-            <a:spAutoFit/>
-          </a:bodyPr>
-          <a:lstStyle/>
-          <a:p>
-            <a:pPr>
-              <a:defRPr sz="1400" b="0">
-                <a:solidFill>
-                  <a:srgbClr val="EBF2FA"/>
-                </a:solidFill>
-              </a:defRPr>
-            </a:pPr>
-            <a:r>
-              <a:t>0.011</a:t>
-            </a:r>
-          </a:p>
-        </p:txBody>
-      </p:sp>
-      <p:sp>
-        <p:nvSpPr>
-          <p:cNvPr id="30" name="TextBox 29"/>
-          <p:cNvSpPr txBox="1"/>
-          <p:nvPr/>
-        </p:nvSpPr>
-        <p:spPr>
-          <a:xfrm>
-            <a:off x="594360" y="4498848"/>
-            <a:ext cx="11094720" cy="411480"/>
-          </a:xfrm>
-          <a:prstGeom prst="rect">
-            <a:avLst/>
-          </a:prstGeom>
-          <a:noFill/>
-        </p:spPr>
-        <p:txBody>
-          <a:bodyPr wrap="square">
-            <a:spAutoFit/>
-          </a:bodyPr>
-          <a:lstStyle/>
-          <a:p>
-            <a:pPr>
-              <a:defRPr sz="1500" b="1">
-                <a:solidFill>
-                  <a:srgbClr val="5BCCE6"/>
-                </a:solidFill>
-              </a:defRPr>
-            </a:pPr>
-            <a:r>
-              <a:t>All four Spark runs passed independent SSE, assignment, and cluster-count checks.</a:t>
-            </a:r>
-          </a:p>
-        </p:txBody>
-      </p:sp>
-      <p:sp>
-        <p:nvSpPr>
-          <p:cNvPr id="31" name="TextBox 30"/>
-          <p:cNvSpPr txBox="1"/>
-          <p:nvPr/>
-        </p:nvSpPr>
-        <p:spPr>
-          <a:xfrm>
-            <a:off x="594360" y="5010912"/>
-            <a:ext cx="11094720" cy="960120"/>
-          </a:xfrm>
-          <a:prstGeom prst="rect">
-            <a:avLst/>
-          </a:prstGeom>
-          <a:noFill/>
-        </p:spPr>
-        <p:txBody>
-          <a:bodyPr wrap="square">
-            <a:spAutoFit/>
-          </a:bodyPr>
-          <a:lstStyle/>
-          <a:p>
-            <a:pPr>
-              <a:defRPr sz="1400" b="0">
-                <a:solidFill>
-                  <a:srgbClr val="EBF2FA"/>
-                </a:solidFill>
-              </a:defRPr>
-            </a:pPr>
-            <a:r>
-              <a:t>KDD99 purity 0.797 is near the 0.795 majority-class reference. This five-cluster check is separate from the earlier four-cluster, 42-run controlled study. Spark local[n] uses one computer.</a:t>
             </a:r>
           </a:p>
         </p:txBody>
@@ -17076,7 +17148,7 @@
           <a:lstStyle/>
           <a:p>
             <a:r>
-              <a:t>03 / 23</a:t>
+              <a:t>03 / 24</a:t>
             </a:r>
           </a:p>
         </p:txBody>
@@ -17721,7 +17793,7 @@
           <a:lstStyle/>
           <a:p>
             <a:r>
-              <a:t>04 / 23</a:t>
+              <a:t>04 / 24</a:t>
             </a:r>
           </a:p>
         </p:txBody>
@@ -18745,7 +18817,7 @@
           <a:lstStyle/>
           <a:p>
             <a:r>
-              <a:t>05 / 23</a:t>
+              <a:t>05 / 24</a:t>
             </a:r>
           </a:p>
         </p:txBody>
@@ -19962,7 +20034,7 @@
           <a:lstStyle/>
           <a:p>
             <a:r>
-              <a:t>06 / 23</a:t>
+              <a:t>06 / 24</a:t>
             </a:r>
           </a:p>
         </p:txBody>
@@ -21168,7 +21240,7 @@
               </a:defRPr>
             </a:pPr>
             <a:r>
-              <a:t>07 / 23</a:t>
+              <a:t>07 / 24</a:t>
             </a:r>
           </a:p>
         </p:txBody>
@@ -21451,7 +21523,7 @@
           <a:lstStyle/>
           <a:p>
             <a:r>
-              <a:t>08 / 23</a:t>
+              <a:t>08 / 24</a:t>
             </a:r>
           </a:p>
         </p:txBody>
@@ -22894,7 +22966,7 @@
               </a:defRPr>
             </a:pPr>
             <a:r>
-              <a:t>09 / 23</a:t>
+              <a:t>09 / 24</a:t>
             </a:r>
           </a:p>
         </p:txBody>

</xml_diff>